<commit_message>
docs(apresentacao): sincronizar apresentacao oficial pdf e pptx com realidade funcional e sobriedade academica
</commit_message>
<xml_diff>
--- a/Apresentacao_SAREL_PPGTCA_2026.pptx
+++ b/Apresentacao_SAREL_PPGTCA_2026.pptx
@@ -18,6 +18,7 @@
     <p:sldId id="266" r:id="rId17"/>
     <p:sldId id="267" r:id="rId18"/>
     <p:sldId id="268" r:id="rId19"/>
+    <p:sldId id="269" r:id="rId20"/>
   </p:sldIdLst>
   <p:sldSz cx="12191695" cy="6858000" type="screen4x3"/>
   <p:notesSz cx="6858000" cy="9144000"/>
@@ -3225,7 +3226,7 @@
               </a:defRPr>
             </a:pPr>
             <a:r>
-              <a:t>• Lei Fundamental &amp; Rigor Anti-Mock</a:t>
+              <a:t>• Rigor Metodológico Anti-Mock</a:t>
             </a:r>
           </a:p>
           <a:p>
@@ -3264,7 +3265,7 @@
               </a:defRPr>
             </a:pPr>
             <a:r>
-              <a:t>559.899 imóveis SICAR-PR + SIGEF + SNCR com máscara byte a byte.</a:t>
+              <a:t>559.899 imóveis SICAR-PR + SIGEF + SNCR com anonimização.</a:t>
             </a:r>
           </a:p>
           <a:p>
@@ -3279,7 +3280,7 @@
               </a:defRPr>
             </a:pPr>
             <a:r>
-              <a:t>• Validação Espacial LOCO</a:t>
+              <a:t>• Validação Espacial Externa LOCO</a:t>
             </a:r>
           </a:p>
           <a:p>
@@ -3291,7 +3292,7 @@
               </a:defRPr>
             </a:pPr>
             <a:r>
-              <a:t>XGBoost Leave-One-Catchment-Out particionado pelas bacias do PR.</a:t>
+              <a:t>Modelagem XGBoost externa particionada por bacias hidrográficas.</a:t>
             </a:r>
           </a:p>
         </p:txBody>
@@ -3334,7 +3335,7 @@
               <a:spcBef>
                 <a:spcPts val="1200"/>
               </a:spcBef>
-              <a:defRPr sz="2700" b="1">
+              <a:defRPr sz="2600" b="1">
                 <a:solidFill>
                   <a:srgbClr val="FFFFFF"/>
                 </a:solidFill>
@@ -3349,7 +3350,7 @@
               <a:spcBef>
                 <a:spcPts val="1200"/>
               </a:spcBef>
-              <a:defRPr sz="1300">
+              <a:defRPr sz="1250">
                 <a:solidFill>
                   <a:srgbClr val="CBD5E1"/>
                 </a:solidFill>
@@ -3364,7 +3365,7 @@
               <a:spcBef>
                 <a:spcPts val="2200"/>
               </a:spcBef>
-              <a:defRPr sz="1100" b="1">
+              <a:defRPr sz="1050" b="1">
                 <a:solidFill>
                   <a:srgbClr val="10B981"/>
                 </a:solidFill>
@@ -3509,7 +3510,7 @@
           <a:lstStyle/>
           <a:p>
             <a:pPr>
-              <a:defRPr sz="2200" b="1">
+              <a:defRPr sz="2100" b="1">
                 <a:solidFill>
                   <a:srgbClr val="FFFFFF"/>
                 </a:solidFill>
@@ -3679,7 +3680,7 @@
               </a:defRPr>
             </a:pPr>
             <a:r>
-              <a:t>Fase A: Interpretação Visual Cega</a:t>
+              <a:t>Fase A: Interpretação Cega</a:t>
             </a:r>
           </a:p>
           <a:p>
@@ -3702,7 +3703,7 @@
                   <a:srgbClr val="475569"/>
                 </a:solidFill>
               </a:rPr>
-              <a:t>Inspeção em resolução de 3m/30cm com data de aquisição visível no visor.</a:t>
+              <a:t>Inspeção em alta resolução com data de aquisição visível no visor.</a:t>
             </a:r>
           </a:p>
           <a:p>
@@ -3725,7 +3726,7 @@
                   <a:srgbClr val="475569"/>
                 </a:solidFill>
               </a:rPr>
-              <a:t>O intérprete desconhece predições do modelo, fatores RUSLE, declividade e estrato.</a:t>
+              <a:t>O intérprete desconhece predições, fatores RUSLE, declividade e estrato.</a:t>
             </a:r>
           </a:p>
           <a:p>
@@ -3748,7 +3749,7 @@
                   <a:srgbClr val="475569"/>
                 </a:solidFill>
               </a:rPr>
-              <a:t>Avaliação de cobertura vegetal, decapitação de solo, carreadores e terraços.</a:t>
+              <a:t>Avaliação de cobertura vegetal, decapitação superficial e terraços.</a:t>
             </a:r>
           </a:p>
         </p:txBody>
@@ -3831,7 +3832,7 @@
               </a:defRPr>
             </a:pPr>
             <a:r>
-              <a:t>Fase B: Validação em Campo (Kobo)</a:t>
+              <a:t>Fase B: Validação de Campo</a:t>
             </a:r>
           </a:p>
           <a:p>
@@ -3854,7 +3855,7 @@
                   <a:srgbClr val="475569"/>
                 </a:solidFill>
               </a:rPr>
-              <a:t>Equipe visita ~20% dos pontos estratificados munida de GNSS RTK e KoboToolbox.</a:t>
+              <a:t>Equipe visita ~20% dos pontos munida de GNSS submétrico e formulário Kobo.</a:t>
             </a:r>
           </a:p>
           <a:p>
@@ -3877,7 +3878,7 @@
                   <a:srgbClr val="475569"/>
                 </a:solidFill>
               </a:rPr>
-              <a:t>A equipe de campo desconhece o rótulo atribuído na Fase A, medindo a taxa de erro humana.</a:t>
+              <a:t>A equipe desconhece o rótulo da Fase A, permitindo avaliar a taxa de erro.</a:t>
             </a:r>
           </a:p>
           <a:p>
@@ -3900,7 +3901,7 @@
                   <a:srgbClr val="475569"/>
                 </a:solidFill>
               </a:rPr>
-              <a:t>Avaliação milimétrica de pedestais de erosão, descalçamento radicular e crosta.</a:t>
+              <a:t>Avaliação de pedestais, descalçamento radicular e crosta superficial.</a:t>
             </a:r>
           </a:p>
         </p:txBody>
@@ -3983,7 +3984,7 @@
               </a:defRPr>
             </a:pPr>
             <a:r>
-              <a:t>Fase C: Concordância Kappa</a:t>
+              <a:t>Fase C: Auditoria Kappa com IC 95%</a:t>
             </a:r>
           </a:p>
           <a:p>
@@ -4006,7 +4007,7 @@
                   <a:srgbClr val="475569"/>
                 </a:solidFill>
               </a:rPr>
-              <a:t>Cálculo rigoroso de concordância inter-observador ajustado ao acaso.</a:t>
+              <a:t>Mede a validade concorrente entre rótulo orbital e verdade de campo.</a:t>
             </a:r>
           </a:p>
           <a:p>
@@ -4021,7 +4022,7 @@
                   <a:srgbClr val="0F172A"/>
                 </a:solidFill>
               </a:rPr>
-              <a:t>Alerta Bloqueante (κ &lt; 0,60): </a:t>
+              <a:t>Intervalo de Confiança: </a:t>
             </a:r>
             <a:r>
               <a:rPr sz="980">
@@ -4029,7 +4030,7 @@
                   <a:srgbClr val="475569"/>
                 </a:solidFill>
               </a:rPr>
-              <a:t>Se a concordância for inferior a substancial (Landis &amp; Koch), a matriz é travada.</a:t>
+              <a:t>Cálculo do Erro-Padrão assintótico e IC 95% contra variações amostrais.</a:t>
             </a:r>
           </a:p>
           <a:p>
@@ -4044,7 +4045,7 @@
                   <a:srgbClr val="0F172A"/>
                 </a:solidFill>
               </a:rPr>
-              <a:t>Resolução de Divergência: </a:t>
+              <a:t>Trava Operacional: </a:t>
             </a:r>
             <a:r>
               <a:rPr sz="980">
@@ -4052,7 +4053,7 @@
                   <a:srgbClr val="475569"/>
                 </a:solidFill>
               </a:rPr>
-              <a:t>Pontos divergentes são arbitrados por perito sênior ou descartados da matriz.</a:t>
+              <a:t>Exige κ ≥ 0,61 (patamar substancial segundo Landis &amp; Koch, 1977).</a:t>
             </a:r>
           </a:p>
         </p:txBody>
@@ -4150,7 +4151,7 @@
                   <a:srgbClr val="0F172A"/>
                 </a:solidFill>
               </a:rPr>
-              <a:t>Ortomosaicos de VANT: </a:t>
+              <a:t>Ortomosaicos Centimétricos: </a:t>
             </a:r>
             <a:r>
               <a:rPr sz="980">
@@ -4158,7 +4159,7 @@
                   <a:srgbClr val="475569"/>
                 </a:solidFill>
               </a:rPr>
-              <a:t>Voo de drone gerando modelos tridimensionais centimétricos nos sítios padrão-ouro.</a:t>
+              <a:t>Voo de drone gerando modelos tridimensionais em sítios de referência.</a:t>
             </a:r>
           </a:p>
           <a:p>
@@ -4181,7 +4182,7 @@
                   <a:srgbClr val="475569"/>
                 </a:solidFill>
               </a:rPr>
-              <a:t>As amostras de drone são mantidas compulsoriamente como conjunto de teste (held-out).</a:t>
+              <a:t>Amostras de drone mantidas compulsoriamente como teste (held-out).</a:t>
             </a:r>
           </a:p>
           <a:p>
@@ -4204,7 +4205,7 @@
                   <a:srgbClr val="475569"/>
                 </a:solidFill>
               </a:rPr>
-              <a:t>Nunca entram no treino do XGBoost, garantindo avaliação final não contaminada.</a:t>
+              <a:t>Isoladas do treino do modelo, garantindo avaliação não contaminada.</a:t>
             </a:r>
           </a:p>
         </p:txBody>
@@ -4338,14 +4339,14 @@
           <a:lstStyle/>
           <a:p>
             <a:pPr>
-              <a:defRPr sz="2200" b="1">
+              <a:defRPr sz="2100" b="1">
                 <a:solidFill>
                   <a:srgbClr val="FFFFFF"/>
                 </a:solidFill>
               </a:defRPr>
             </a:pPr>
             <a:r>
-              <a:t>Modelagem Preditiva: XGBoost com Validação Cruzada Espacial LOCO</a:t>
+              <a:t>Modelagem Preditiva Externa: XGBoost LOCO &amp; Explicabilidade SHAP</a:t>
             </a:r>
           </a:p>
         </p:txBody>
@@ -4508,7 +4509,7 @@
               </a:defRPr>
             </a:pPr>
             <a:r>
-              <a:t>Por que LOCO e não K-Fold Tradicional?</a:t>
+              <a:t>Validação Cruzada LOCO</a:t>
             </a:r>
           </a:p>
           <a:p>
@@ -4531,7 +4532,7 @@
                   <a:srgbClr val="475569"/>
                 </a:solidFill>
               </a:rPr>
-              <a:t>Amostras geoespaciais próximas violam a premissa i.i.d. O K-Fold comum mistura pixels vizinhos, inflacionando a acurácia.</a:t>
+              <a:t>Amostras geoespaciais violam a premissa i.i.d. O K-Fold comum mistura pixels vizinhos, inflando métricas.</a:t>
             </a:r>
           </a:p>
           <a:p>
@@ -4554,7 +4555,7 @@
                   <a:srgbClr val="475569"/>
                 </a:solidFill>
               </a:rPr>
-              <a:t>O algoritmo treina em 4 macrobacias hidrográficas do Paraná e é testado na 5ª bacia inteiramente omitida.</a:t>
+              <a:t>O algoritmo treina em bacias hidrográficas e é testado em uma bacia inteiramente retida (Roberts et al., 2017).</a:t>
             </a:r>
           </a:p>
           <a:p>
@@ -4577,7 +4578,7 @@
                   <a:srgbClr val="475569"/>
                 </a:solidFill>
               </a:rPr>
-              <a:t>Mede a eficácia real do método em extrapolar a predição para novos territórios sem vazamento de vizinhança.</a:t>
+              <a:t>Mede a capacidade real de extrapolação espacial do modelo sem vazamento territorial.</a:t>
             </a:r>
           </a:p>
         </p:txBody>
@@ -4683,7 +4684,7 @@
                   <a:srgbClr val="475569"/>
                 </a:solidFill>
               </a:rPr>
-              <a:t>Mede a contribuição marginal de cada variável preditora (NDVI, BSI, Declividade, K, R) na decisão do modelo.</a:t>
+              <a:t>Mede a contribuição marginal de cada variável preditora na saída do classificador (Lundberg &amp; Lee, 2017).</a:t>
             </a:r>
           </a:p>
           <a:p>
@@ -4706,7 +4707,7 @@
                   <a:srgbClr val="475569"/>
                 </a:solidFill>
               </a:rPr>
-              <a:t>Garante que a erosão seja atribuída a processos físicos reais (alta declividade + solo exposto), e não a ruídos estatísticos.</a:t>
+              <a:t>Verifica se a predição reflete processos biofísicos reais (alta declividade + solo exposto), e não ruídos de amostragem.</a:t>
             </a:r>
           </a:p>
           <a:p>
@@ -4721,7 +4722,7 @@
                   <a:srgbClr val="0F172A"/>
                 </a:solidFill>
               </a:rPr>
-              <a:t>Entregáveis da Dissertação: </a:t>
+              <a:t>Entregáveis da Pesquisa: </a:t>
             </a:r>
             <a:r>
               <a:rPr sz="1019">
@@ -4729,7 +4730,7 @@
                   <a:srgbClr val="475569"/>
                 </a:solidFill>
               </a:rPr>
-              <a:t>Gráficos SHAP Summary (Beeswarm Plot) e gráficos de dependência parcial revelando limiares críticos.</a:t>
+              <a:t>Gráficos SHAP Summary e dependência parcial revelando limiares críticos na paisagem.</a:t>
             </a:r>
           </a:p>
         </p:txBody>
@@ -4812,7 +4813,7 @@
               </a:defRPr>
             </a:pPr>
             <a:r>
-              <a:t>Métricas Científicas Reais Esperadas</a:t>
+              <a:t>Métricas Científicas Realistas</a:t>
             </a:r>
           </a:p>
           <a:p>
@@ -4827,7 +4828,7 @@
                   <a:srgbClr val="0F172A"/>
                 </a:solidFill>
               </a:rPr>
-              <a:t>Acurácia Realista (84% a 93%): </a:t>
+              <a:t>Discriminação vs Calibração: </a:t>
             </a:r>
             <a:r>
               <a:rPr sz="1019">
@@ -4835,7 +4836,7 @@
                   <a:srgbClr val="475569"/>
                 </a:solidFill>
               </a:rPr>
-              <a:t>Ambientes naturais e sensores orbitais possuem ruídos. Resultados de 100% decorrem de vícios e foram barrados.</a:t>
+              <a:t>Acurácia realista esperada entre 82% e 91%; ROC-AUC avalia discriminação, enquanto Brier Score avalia calibração.</a:t>
             </a:r>
           </a:p>
           <a:p>
@@ -4850,7 +4851,7 @@
                   <a:srgbClr val="0F172A"/>
                 </a:solidFill>
               </a:rPr>
-              <a:t>ROC-AUC Esperada (0,88 a 0,95): </a:t>
+              <a:t>Remoção da Perda RUSLE: </a:t>
             </a:r>
             <a:r>
               <a:rPr sz="1019">
@@ -4858,7 +4859,7 @@
                   <a:srgbClr val="475569"/>
                 </a:solidFill>
               </a:rPr>
-              <a:t>Desempenho de alta separabilidade com calibração probabilística rigorosa.</a:t>
+              <a:t>A perda de solo calculada foi formalmente removida da matriz de treino, evitando qualquer circularidade.</a:t>
             </a:r>
           </a:p>
           <a:p>
@@ -4873,7 +4874,7 @@
                   <a:srgbClr val="0F172A"/>
                 </a:solidFill>
               </a:rPr>
-              <a:t>Integridade Assegurada: </a:t>
+              <a:t>Trava Anti-Mock Ativa: </a:t>
             </a:r>
             <a:r>
               <a:rPr sz="1019">
@@ -4881,7 +4882,7 @@
                   <a:srgbClr val="475569"/>
                 </a:solidFill>
               </a:rPr>
-              <a:t>O script Python treinar_xgboost_loco.py possui trava anti-mock ativa que exige dados reais.</a:t>
+              <a:t>O script treinar_xgboost_loco.py possui validação que barra matrizes sintéticas ou constantes residuais.</a:t>
             </a:r>
           </a:p>
         </p:txBody>
@@ -5015,14 +5016,14 @@
           <a:lstStyle/>
           <a:p>
             <a:pPr>
-              <a:defRPr sz="2200" b="1">
+              <a:defRPr sz="2100" b="1">
                 <a:solidFill>
                   <a:srgbClr val="FFFFFF"/>
                 </a:solidFill>
               </a:defRPr>
             </a:pPr>
             <a:r>
-              <a:t>Invariantes de Exportação: 7 Portões de Segurança Contra Falhas</a:t>
+              <a:t>Invariantes de Integridade: 7 Portões de Auditoria de Dados</a:t>
             </a:r>
           </a:p>
         </p:txBody>
@@ -6082,7 +6083,7 @@
                   <a:srgbClr val="475569"/>
                 </a:solidFill>
               </a:rPr>
-              <a:t>Nenhuma coluna numérica tem valor idêntico em todas as linhas (N ≥ 21), impedindo vícios legados.</a:t>
+              <a:t>Bloqueia colunas numéricas com valor idêntico (N ≥ 21), exceto fatores tabelados com proveniência explícita.</a:t>
             </a:r>
           </a:p>
         </p:txBody>
@@ -6096,6 +6097,835 @@
 </file>
 
 <file path=ppt/slides/slide13.xml><?xml version="1.0" encoding="utf-8"?>
+<p:sld xmlns:a="http://schemas.openxmlformats.org/drawingml/2006/main" xmlns:p="http://schemas.openxmlformats.org/presentationml/2006/main" xmlns:r="http://schemas.openxmlformats.org/officeDocument/2006/relationships">
+  <p:cSld>
+    <p:bg>
+      <p:bgPr>
+        <a:solidFill>
+          <a:srgbClr val="F8FAFC"/>
+        </a:solidFill>
+        <a:effectLst/>
+      </p:bgPr>
+    </p:bg>
+    <p:spTree>
+      <p:nvGrpSpPr>
+        <p:cNvPr id="1" name=""/>
+        <p:cNvGrpSpPr/>
+        <p:nvPr/>
+      </p:nvGrpSpPr>
+      <p:grpSpPr/>
+      <p:sp>
+        <p:nvSpPr>
+          <p:cNvPr id="2" name="Rectangle 1"/>
+          <p:cNvSpPr/>
+          <p:nvPr/>
+        </p:nvSpPr>
+        <p:spPr>
+          <a:xfrm>
+            <a:off x="0" y="0"/>
+            <a:ext cx="12191695" cy="1051560"/>
+          </a:xfrm>
+          <a:prstGeom prst="rect">
+            <a:avLst/>
+          </a:prstGeom>
+          <a:solidFill>
+            <a:srgbClr val="0F172A"/>
+          </a:solidFill>
+          <a:ln>
+            <a:solidFill>
+              <a:srgbClr val="0F172A"/>
+            </a:solidFill>
+          </a:ln>
+        </p:spPr>
+        <p:style>
+          <a:lnRef idx="1">
+            <a:schemeClr val="accent1"/>
+          </a:lnRef>
+          <a:fillRef idx="3">
+            <a:schemeClr val="accent1"/>
+          </a:fillRef>
+          <a:effectRef idx="2">
+            <a:schemeClr val="accent1"/>
+          </a:effectRef>
+          <a:fontRef idx="minor">
+            <a:schemeClr val="lt1"/>
+          </a:fontRef>
+        </p:style>
+        <p:txBody>
+          <a:bodyPr rtlCol="0" anchor="ctr"/>
+          <a:lstStyle/>
+          <a:p>
+            <a:pPr algn="ctr"/>
+          </a:p>
+        </p:txBody>
+      </p:sp>
+      <p:sp>
+        <p:nvSpPr>
+          <p:cNvPr id="3" name="TextBox 2"/>
+          <p:cNvSpPr txBox="1"/>
+          <p:nvPr/>
+        </p:nvSpPr>
+        <p:spPr>
+          <a:xfrm>
+            <a:off x="731520" y="109728"/>
+            <a:ext cx="10698480" cy="274320"/>
+          </a:xfrm>
+          <a:prstGeom prst="rect">
+            <a:avLst/>
+          </a:prstGeom>
+          <a:noFill/>
+        </p:spPr>
+        <p:txBody>
+          <a:bodyPr wrap="square">
+            <a:spAutoFit/>
+          </a:bodyPr>
+          <a:lstStyle/>
+          <a:p>
+            <a:pPr>
+              <a:defRPr sz="950" b="1">
+                <a:solidFill>
+                  <a:srgbClr val="10B981"/>
+                </a:solidFill>
+              </a:defRPr>
+            </a:pPr>
+            <a:r>
+              <a:t>TRANSPARÊNCIA CIENTÍFICA &amp; LIMITES DE VALIDADE</a:t>
+            </a:r>
+          </a:p>
+        </p:txBody>
+      </p:sp>
+      <p:sp>
+        <p:nvSpPr>
+          <p:cNvPr id="4" name="TextBox 3"/>
+          <p:cNvSpPr txBox="1"/>
+          <p:nvPr/>
+        </p:nvSpPr>
+        <p:spPr>
+          <a:xfrm>
+            <a:off x="731520" y="347472"/>
+            <a:ext cx="10698480" cy="594360"/>
+          </a:xfrm>
+          <a:prstGeom prst="rect">
+            <a:avLst/>
+          </a:prstGeom>
+          <a:noFill/>
+        </p:spPr>
+        <p:txBody>
+          <a:bodyPr wrap="square">
+            <a:spAutoFit/>
+          </a:bodyPr>
+          <a:lstStyle/>
+          <a:p>
+            <a:pPr>
+              <a:defRPr sz="2100" b="1">
+                <a:solidFill>
+                  <a:srgbClr val="FFFFFF"/>
+                </a:solidFill>
+              </a:defRPr>
+            </a:pPr>
+            <a:r>
+              <a:t>Limitações Metodológicas &amp; Desafios da Operação Real</a:t>
+            </a:r>
+          </a:p>
+        </p:txBody>
+      </p:sp>
+      <p:sp>
+        <p:nvSpPr>
+          <p:cNvPr id="5" name="Rectangle 4"/>
+          <p:cNvSpPr/>
+          <p:nvPr/>
+        </p:nvSpPr>
+        <p:spPr>
+          <a:xfrm>
+            <a:off x="0" y="1051560"/>
+            <a:ext cx="12191695" cy="45720"/>
+          </a:xfrm>
+          <a:prstGeom prst="rect">
+            <a:avLst/>
+          </a:prstGeom>
+          <a:solidFill>
+            <a:srgbClr val="10B981"/>
+          </a:solidFill>
+          <a:ln>
+            <a:solidFill>
+              <a:srgbClr val="10B981"/>
+            </a:solidFill>
+          </a:ln>
+        </p:spPr>
+        <p:style>
+          <a:lnRef idx="1">
+            <a:schemeClr val="accent1"/>
+          </a:lnRef>
+          <a:fillRef idx="3">
+            <a:schemeClr val="accent1"/>
+          </a:fillRef>
+          <a:effectRef idx="2">
+            <a:schemeClr val="accent1"/>
+          </a:effectRef>
+          <a:fontRef idx="minor">
+            <a:schemeClr val="lt1"/>
+          </a:fontRef>
+        </p:style>
+        <p:txBody>
+          <a:bodyPr rtlCol="0" anchor="ctr"/>
+          <a:lstStyle/>
+          <a:p>
+            <a:pPr algn="ctr"/>
+          </a:p>
+        </p:txBody>
+      </p:sp>
+      <p:sp>
+        <p:nvSpPr>
+          <p:cNvPr id="6" name="TextBox 5"/>
+          <p:cNvSpPr txBox="1"/>
+          <p:nvPr/>
+        </p:nvSpPr>
+        <p:spPr>
+          <a:xfrm>
+            <a:off x="731520" y="6510528"/>
+            <a:ext cx="10698480" cy="274320"/>
+          </a:xfrm>
+          <a:prstGeom prst="rect">
+            <a:avLst/>
+          </a:prstGeom>
+          <a:noFill/>
+        </p:spPr>
+        <p:txBody>
+          <a:bodyPr wrap="none">
+            <a:spAutoFit/>
+          </a:bodyPr>
+          <a:lstStyle/>
+          <a:p>
+            <a:pPr>
+              <a:defRPr sz="850">
+                <a:solidFill>
+                  <a:srgbClr val="475569"/>
+                </a:solidFill>
+              </a:defRPr>
+            </a:pPr>
+            <a:r>
+              <a:t>SAREL v2.0 • Sistema de Amostragem e Rotulagem para Erosão Laminar • PPGTCA 2026</a:t>
+            </a:r>
+          </a:p>
+        </p:txBody>
+      </p:sp>
+      <p:sp>
+        <p:nvSpPr>
+          <p:cNvPr id="7" name="Rounded Rectangle 6"/>
+          <p:cNvSpPr/>
+          <p:nvPr/>
+        </p:nvSpPr>
+        <p:spPr>
+          <a:xfrm>
+            <a:off x="731520" y="1417320"/>
+            <a:ext cx="5212080" cy="2240280"/>
+          </a:xfrm>
+          <a:prstGeom prst="roundRect">
+            <a:avLst/>
+          </a:prstGeom>
+          <a:solidFill>
+            <a:srgbClr val="FFFFFF"/>
+          </a:solidFill>
+          <a:ln w="15240">
+            <a:solidFill>
+              <a:srgbClr val="E2E8F0"/>
+            </a:solidFill>
+          </a:ln>
+        </p:spPr>
+        <p:style>
+          <a:lnRef idx="1">
+            <a:schemeClr val="accent1"/>
+          </a:lnRef>
+          <a:fillRef idx="3">
+            <a:schemeClr val="accent1"/>
+          </a:fillRef>
+          <a:effectRef idx="2">
+            <a:schemeClr val="accent1"/>
+          </a:effectRef>
+          <a:fontRef idx="minor">
+            <a:schemeClr val="lt1"/>
+          </a:fontRef>
+        </p:style>
+        <p:txBody>
+          <a:bodyPr rtlCol="0" anchor="ctr"/>
+          <a:lstStyle/>
+          <a:p>
+            <a:pPr algn="ctr"/>
+          </a:p>
+        </p:txBody>
+      </p:sp>
+      <p:sp>
+        <p:nvSpPr>
+          <p:cNvPr id="8" name="TextBox 7"/>
+          <p:cNvSpPr txBox="1"/>
+          <p:nvPr/>
+        </p:nvSpPr>
+        <p:spPr>
+          <a:xfrm>
+            <a:off x="914400" y="1600200"/>
+            <a:ext cx="4846320" cy="1874520"/>
+          </a:xfrm>
+          <a:prstGeom prst="rect">
+            <a:avLst/>
+          </a:prstGeom>
+          <a:noFill/>
+        </p:spPr>
+        <p:txBody>
+          <a:bodyPr wrap="square">
+            <a:spAutoFit/>
+          </a:bodyPr>
+          <a:lstStyle/>
+          <a:p>
+            <a:pPr>
+              <a:spcAft>
+                <a:spcPts val="500"/>
+              </a:spcAft>
+              <a:defRPr sz="1300" b="1">
+                <a:solidFill>
+                  <a:srgbClr val="D97706"/>
+                </a:solidFill>
+              </a:defRPr>
+            </a:pPr>
+            <a:r>
+              <a:t>Resolução Espacial de 30 metros</a:t>
+            </a:r>
+          </a:p>
+          <a:p>
+            <a:pPr>
+              <a:spcAft>
+                <a:spcPts val="400"/>
+              </a:spcAft>
+            </a:pPr>
+            <a:r>
+              <a:rPr b="1" sz="1000">
+                <a:solidFill>
+                  <a:srgbClr val="0F172A"/>
+                </a:solidFill>
+              </a:rPr>
+              <a:t>Tamanho do Pixel: </a:t>
+            </a:r>
+            <a:r>
+              <a:rPr sz="1000">
+                <a:solidFill>
+                  <a:srgbClr val="475569"/>
+                </a:solidFill>
+              </a:rPr>
+              <a:t>Copernicus DEM (30m) suaviza microtopografia, feições de microrrelevo e terraços estreitos.</a:t>
+            </a:r>
+          </a:p>
+          <a:p>
+            <a:pPr>
+              <a:spcAft>
+                <a:spcPts val="400"/>
+              </a:spcAft>
+            </a:pPr>
+            <a:r>
+              <a:rPr b="1" sz="1000">
+                <a:solidFill>
+                  <a:srgbClr val="0F172A"/>
+                </a:solidFill>
+              </a:rPr>
+              <a:t>Consequência: </a:t>
+            </a:r>
+            <a:r>
+              <a:rPr sz="1000">
+                <a:solidFill>
+                  <a:srgbClr val="475569"/>
+                </a:solidFill>
+              </a:rPr>
+              <a:t>Pode subestimar localmente a declividade em talvegues abruptos ou rupturas de declive acentuadas.</a:t>
+            </a:r>
+          </a:p>
+          <a:p>
+            <a:pPr>
+              <a:spcAft>
+                <a:spcPts val="400"/>
+              </a:spcAft>
+            </a:pPr>
+            <a:r>
+              <a:rPr b="1" sz="1000">
+                <a:solidFill>
+                  <a:srgbClr val="0F172A"/>
+                </a:solidFill>
+              </a:rPr>
+              <a:t>Atenuação: </a:t>
+            </a:r>
+            <a:r>
+              <a:rPr sz="1000">
+                <a:solidFill>
+                  <a:srgbClr val="475569"/>
+                </a:solidFill>
+              </a:rPr>
+              <a:t>Uso complementar de ortomosaicos de drone (GSD &lt; 5cm) nas áreas de calibração presencial.</a:t>
+            </a:r>
+          </a:p>
+        </p:txBody>
+      </p:sp>
+      <p:sp>
+        <p:nvSpPr>
+          <p:cNvPr id="9" name="Rounded Rectangle 8"/>
+          <p:cNvSpPr/>
+          <p:nvPr/>
+        </p:nvSpPr>
+        <p:spPr>
+          <a:xfrm>
+            <a:off x="6217920" y="1417320"/>
+            <a:ext cx="5212080" cy="2240280"/>
+          </a:xfrm>
+          <a:prstGeom prst="roundRect">
+            <a:avLst/>
+          </a:prstGeom>
+          <a:solidFill>
+            <a:srgbClr val="FFFFFF"/>
+          </a:solidFill>
+          <a:ln w="15240">
+            <a:solidFill>
+              <a:srgbClr val="E2E8F0"/>
+            </a:solidFill>
+          </a:ln>
+        </p:spPr>
+        <p:style>
+          <a:lnRef idx="1">
+            <a:schemeClr val="accent1"/>
+          </a:lnRef>
+          <a:fillRef idx="3">
+            <a:schemeClr val="accent1"/>
+          </a:fillRef>
+          <a:effectRef idx="2">
+            <a:schemeClr val="accent1"/>
+          </a:effectRef>
+          <a:fontRef idx="minor">
+            <a:schemeClr val="lt1"/>
+          </a:fontRef>
+        </p:style>
+        <p:txBody>
+          <a:bodyPr rtlCol="0" anchor="ctr"/>
+          <a:lstStyle/>
+          <a:p>
+            <a:pPr algn="ctr"/>
+          </a:p>
+        </p:txBody>
+      </p:sp>
+      <p:sp>
+        <p:nvSpPr>
+          <p:cNvPr id="10" name="TextBox 9"/>
+          <p:cNvSpPr txBox="1"/>
+          <p:nvPr/>
+        </p:nvSpPr>
+        <p:spPr>
+          <a:xfrm>
+            <a:off x="6400800" y="1600200"/>
+            <a:ext cx="4846320" cy="1874520"/>
+          </a:xfrm>
+          <a:prstGeom prst="rect">
+            <a:avLst/>
+          </a:prstGeom>
+          <a:noFill/>
+        </p:spPr>
+        <p:txBody>
+          <a:bodyPr wrap="square">
+            <a:spAutoFit/>
+          </a:bodyPr>
+          <a:lstStyle/>
+          <a:p>
+            <a:pPr>
+              <a:spcAft>
+                <a:spcPts val="500"/>
+              </a:spcAft>
+              <a:defRPr sz="1300" b="1">
+                <a:solidFill>
+                  <a:srgbClr val="E11D48"/>
+                </a:solidFill>
+              </a:defRPr>
+            </a:pPr>
+            <a:r>
+              <a:t>Persistência de Cobertura de Nuvens</a:t>
+            </a:r>
+          </a:p>
+          <a:p>
+            <a:pPr>
+              <a:spcAft>
+                <a:spcPts val="400"/>
+              </a:spcAft>
+            </a:pPr>
+            <a:r>
+              <a:rPr b="1" sz="1000">
+                <a:solidFill>
+                  <a:srgbClr val="0F172A"/>
+                </a:solidFill>
+              </a:rPr>
+              <a:t>Região Sul do Brasil: </a:t>
+            </a:r>
+            <a:r>
+              <a:rPr sz="1000">
+                <a:solidFill>
+                  <a:srgbClr val="475569"/>
+                </a:solidFill>
+              </a:rPr>
+              <a:t>Elevada nebulosidade em períodos chuvosos críticos de primavera e verão.</a:t>
+            </a:r>
+          </a:p>
+          <a:p>
+            <a:pPr>
+              <a:spcAft>
+                <a:spcPts val="400"/>
+              </a:spcAft>
+            </a:pPr>
+            <a:r>
+              <a:rPr b="1" sz="1000">
+                <a:solidFill>
+                  <a:srgbClr val="0F172A"/>
+                </a:solidFill>
+              </a:rPr>
+              <a:t>Consequência: </a:t>
+            </a:r>
+            <a:r>
+              <a:rPr sz="1000">
+                <a:solidFill>
+                  <a:srgbClr val="475569"/>
+                </a:solidFill>
+              </a:rPr>
+              <a:t>Redução do número de imagens úteis no Sentinel-2 e janelas de observação truncadas.</a:t>
+            </a:r>
+          </a:p>
+          <a:p>
+            <a:pPr>
+              <a:spcAft>
+                <a:spcPts val="400"/>
+              </a:spcAft>
+            </a:pPr>
+            <a:r>
+              <a:rPr b="1" sz="1000">
+                <a:solidFill>
+                  <a:srgbClr val="0F172A"/>
+                </a:solidFill>
+              </a:rPr>
+              <a:t>Atenuação: </a:t>
+            </a:r>
+            <a:r>
+              <a:rPr sz="1000">
+                <a:solidFill>
+                  <a:srgbClr val="475569"/>
+                </a:solidFill>
+              </a:rPr>
+              <a:t>Composição temporal com BSI, máscaras estritas de nuvem/sombra e séries de múltiplos anos.</a:t>
+            </a:r>
+          </a:p>
+        </p:txBody>
+      </p:sp>
+      <p:sp>
+        <p:nvSpPr>
+          <p:cNvPr id="11" name="Rounded Rectangle 10"/>
+          <p:cNvSpPr/>
+          <p:nvPr/>
+        </p:nvSpPr>
+        <p:spPr>
+          <a:xfrm>
+            <a:off x="731520" y="3840480"/>
+            <a:ext cx="5212080" cy="2240280"/>
+          </a:xfrm>
+          <a:prstGeom prst="roundRect">
+            <a:avLst/>
+          </a:prstGeom>
+          <a:solidFill>
+            <a:srgbClr val="FFFFFF"/>
+          </a:solidFill>
+          <a:ln w="15240">
+            <a:solidFill>
+              <a:srgbClr val="E2E8F0"/>
+            </a:solidFill>
+          </a:ln>
+        </p:spPr>
+        <p:style>
+          <a:lnRef idx="1">
+            <a:schemeClr val="accent1"/>
+          </a:lnRef>
+          <a:fillRef idx="3">
+            <a:schemeClr val="accent1"/>
+          </a:fillRef>
+          <a:effectRef idx="2">
+            <a:schemeClr val="accent1"/>
+          </a:effectRef>
+          <a:fontRef idx="minor">
+            <a:schemeClr val="lt1"/>
+          </a:fontRef>
+        </p:style>
+        <p:txBody>
+          <a:bodyPr rtlCol="0" anchor="ctr"/>
+          <a:lstStyle/>
+          <a:p>
+            <a:pPr algn="ctr"/>
+          </a:p>
+        </p:txBody>
+      </p:sp>
+      <p:sp>
+        <p:nvSpPr>
+          <p:cNvPr id="12" name="TextBox 11"/>
+          <p:cNvSpPr txBox="1"/>
+          <p:nvPr/>
+        </p:nvSpPr>
+        <p:spPr>
+          <a:xfrm>
+            <a:off x="914400" y="4023360"/>
+            <a:ext cx="4846320" cy="1874520"/>
+          </a:xfrm>
+          <a:prstGeom prst="rect">
+            <a:avLst/>
+          </a:prstGeom>
+          <a:noFill/>
+        </p:spPr>
+        <p:txBody>
+          <a:bodyPr wrap="square">
+            <a:spAutoFit/>
+          </a:bodyPr>
+          <a:lstStyle/>
+          <a:p>
+            <a:pPr>
+              <a:spcAft>
+                <a:spcPts val="500"/>
+              </a:spcAft>
+              <a:defRPr sz="1300" b="1">
+                <a:solidFill>
+                  <a:srgbClr val="6366F1"/>
+                </a:solidFill>
+              </a:defRPr>
+            </a:pPr>
+            <a:r>
+              <a:t>Viés de Consentimento dos Produtores</a:t>
+            </a:r>
+          </a:p>
+          <a:p>
+            <a:pPr>
+              <a:spcAft>
+                <a:spcPts val="400"/>
+              </a:spcAft>
+            </a:pPr>
+            <a:r>
+              <a:rPr b="1" sz="1000">
+                <a:solidFill>
+                  <a:srgbClr val="0F172A"/>
+                </a:solidFill>
+              </a:rPr>
+              <a:t>Acesso aos Imóveis: </a:t>
+            </a:r>
+            <a:r>
+              <a:rPr sz="1000">
+                <a:solidFill>
+                  <a:srgbClr val="475569"/>
+                </a:solidFill>
+              </a:rPr>
+              <a:t>A validação presencial exige autorização formal de entrada pelo titular do imóvel rural.</a:t>
+            </a:r>
+          </a:p>
+          <a:p>
+            <a:pPr>
+              <a:spcAft>
+                <a:spcPts val="400"/>
+              </a:spcAft>
+            </a:pPr>
+            <a:r>
+              <a:rPr b="1" sz="1000">
+                <a:solidFill>
+                  <a:srgbClr val="0F172A"/>
+                </a:solidFill>
+              </a:rPr>
+              <a:t>Consequência: </a:t>
+            </a:r>
+            <a:r>
+              <a:rPr sz="1000">
+                <a:solidFill>
+                  <a:srgbClr val="475569"/>
+                </a:solidFill>
+              </a:rPr>
+              <a:t>Possível viés amostral de proprietários mais colaborativos e com manejo potencialmente superior.</a:t>
+            </a:r>
+          </a:p>
+          <a:p>
+            <a:pPr>
+              <a:spcAft>
+                <a:spcPts val="400"/>
+              </a:spcAft>
+            </a:pPr>
+            <a:r>
+              <a:rPr b="1" sz="1000">
+                <a:solidFill>
+                  <a:srgbClr val="0F172A"/>
+                </a:solidFill>
+              </a:rPr>
+              <a:t>Atenuação: </a:t>
+            </a:r>
+            <a:r>
+              <a:rPr sz="1000">
+                <a:solidFill>
+                  <a:srgbClr val="475569"/>
+                </a:solidFill>
+              </a:rPr>
+              <a:t>Condução de fotointerpretação cega independente e geolocalização com amostragem balanceada.</a:t>
+            </a:r>
+          </a:p>
+        </p:txBody>
+      </p:sp>
+      <p:sp>
+        <p:nvSpPr>
+          <p:cNvPr id="13" name="Rounded Rectangle 12"/>
+          <p:cNvSpPr/>
+          <p:nvPr/>
+        </p:nvSpPr>
+        <p:spPr>
+          <a:xfrm>
+            <a:off x="6217920" y="3840480"/>
+            <a:ext cx="5212080" cy="2240280"/>
+          </a:xfrm>
+          <a:prstGeom prst="roundRect">
+            <a:avLst/>
+          </a:prstGeom>
+          <a:solidFill>
+            <a:srgbClr val="FFFFFF"/>
+          </a:solidFill>
+          <a:ln w="15240">
+            <a:solidFill>
+              <a:srgbClr val="E2E8F0"/>
+            </a:solidFill>
+          </a:ln>
+        </p:spPr>
+        <p:style>
+          <a:lnRef idx="1">
+            <a:schemeClr val="accent1"/>
+          </a:lnRef>
+          <a:fillRef idx="3">
+            <a:schemeClr val="accent1"/>
+          </a:fillRef>
+          <a:effectRef idx="2">
+            <a:schemeClr val="accent1"/>
+          </a:effectRef>
+          <a:fontRef idx="minor">
+            <a:schemeClr val="lt1"/>
+          </a:fontRef>
+        </p:style>
+        <p:txBody>
+          <a:bodyPr rtlCol="0" anchor="ctr"/>
+          <a:lstStyle/>
+          <a:p>
+            <a:pPr algn="ctr"/>
+          </a:p>
+        </p:txBody>
+      </p:sp>
+      <p:sp>
+        <p:nvSpPr>
+          <p:cNvPr id="14" name="TextBox 13"/>
+          <p:cNvSpPr txBox="1"/>
+          <p:nvPr/>
+        </p:nvSpPr>
+        <p:spPr>
+          <a:xfrm>
+            <a:off x="6400800" y="4023360"/>
+            <a:ext cx="4846320" cy="1874520"/>
+          </a:xfrm>
+          <a:prstGeom prst="rect">
+            <a:avLst/>
+          </a:prstGeom>
+          <a:noFill/>
+        </p:spPr>
+        <p:txBody>
+          <a:bodyPr wrap="square">
+            <a:spAutoFit/>
+          </a:bodyPr>
+          <a:lstStyle/>
+          <a:p>
+            <a:pPr>
+              <a:spcAft>
+                <a:spcPts val="500"/>
+              </a:spcAft>
+              <a:defRPr sz="1300" b="1">
+                <a:solidFill>
+                  <a:srgbClr val="0EA5E9"/>
+                </a:solidFill>
+              </a:defRPr>
+            </a:pPr>
+            <a:r>
+              <a:t>Descasamento Temporal Solo-Sensor</a:t>
+            </a:r>
+          </a:p>
+          <a:p>
+            <a:pPr>
+              <a:spcAft>
+                <a:spcPts val="400"/>
+              </a:spcAft>
+            </a:pPr>
+            <a:r>
+              <a:rPr b="1" sz="1000">
+                <a:solidFill>
+                  <a:srgbClr val="0F172A"/>
+                </a:solidFill>
+              </a:rPr>
+              <a:t>Dinâmica Agrícola: </a:t>
+            </a:r>
+            <a:r>
+              <a:rPr sz="1000">
+                <a:solidFill>
+                  <a:srgbClr val="475569"/>
+                </a:solidFill>
+              </a:rPr>
+              <a:t>Eventos de chuva intensa podem ocorrer entre as passagens orbitais de 5 dias do Sentinel-2.</a:t>
+            </a:r>
+          </a:p>
+          <a:p>
+            <a:pPr>
+              <a:spcAft>
+                <a:spcPts val="400"/>
+              </a:spcAft>
+            </a:pPr>
+            <a:r>
+              <a:rPr b="1" sz="1000">
+                <a:solidFill>
+                  <a:srgbClr val="0F172A"/>
+                </a:solidFill>
+              </a:rPr>
+              <a:t>Consequência: </a:t>
+            </a:r>
+            <a:r>
+              <a:rPr sz="1000">
+                <a:solidFill>
+                  <a:srgbClr val="475569"/>
+                </a:solidFill>
+              </a:rPr>
+              <a:t>Erosão ocorrida logo após o preparo do solo pode ser mascarada pelo rápido crescimento de plantas.</a:t>
+            </a:r>
+          </a:p>
+          <a:p>
+            <a:pPr>
+              <a:spcAft>
+                <a:spcPts val="400"/>
+              </a:spcAft>
+            </a:pPr>
+            <a:r>
+              <a:rPr b="1" sz="1000">
+                <a:solidFill>
+                  <a:srgbClr val="0F172A"/>
+                </a:solidFill>
+              </a:rPr>
+              <a:t>Atenuação: </a:t>
+            </a:r>
+            <a:r>
+              <a:rPr sz="1000">
+                <a:solidFill>
+                  <a:srgbClr val="475569"/>
+                </a:solidFill>
+              </a:rPr>
+              <a:t>Registro da data exata de cada observação e análise da série histórica de solo exposto (Ê).</a:t>
+            </a:r>
+          </a:p>
+        </p:txBody>
+      </p:sp>
+    </p:spTree>
+  </p:cSld>
+  <p:clrMapOvr>
+    <a:masterClrMapping/>
+  </p:clrMapOvr>
+</p:sld>
+</file>
+
+<file path=ppt/slides/slide14.xml><?xml version="1.0" encoding="utf-8"?>
 <p:sld xmlns:a="http://schemas.openxmlformats.org/drawingml/2006/main" xmlns:p="http://schemas.openxmlformats.org/presentationml/2006/main" xmlns:r="http://schemas.openxmlformats.org/officeDocument/2006/relationships">
   <p:cSld>
     <p:bg>
@@ -6121,8 +6951,8 @@
         </p:nvSpPr>
         <p:spPr>
           <a:xfrm>
-            <a:off x="914400" y="1005840"/>
-            <a:ext cx="10362895" cy="5120640"/>
+            <a:off x="731520" y="1005840"/>
+            <a:ext cx="5486400" cy="5120640"/>
           </a:xfrm>
           <a:prstGeom prst="rect">
             <a:avLst/>
@@ -6136,14 +6966,29 @@
           <a:lstStyle/>
           <a:p>
             <a:pPr>
-              <a:defRPr sz="1200" b="1">
+              <a:defRPr sz="1100" b="1">
                 <a:solidFill>
                   <a:srgbClr val="10B981"/>
                 </a:solidFill>
               </a:defRPr>
             </a:pPr>
             <a:r>
-              <a:t>CONCLUSÃO &amp; CONTRIBUIÇÕES PARA O AGRONEGÓCIO PARANAENSE</a:t>
+              <a:t>CONCLUSÃO &amp; CONTRIBUIÇÃO CIENTÍFICA</a:t>
+            </a:r>
+          </a:p>
+          <a:p>
+            <a:pPr>
+              <a:spcBef>
+                <a:spcPts val="600"/>
+              </a:spcBef>
+              <a:defRPr sz="2200" b="1">
+                <a:solidFill>
+                  <a:srgbClr val="FFFFFF"/>
+                </a:solidFill>
+              </a:defRPr>
+            </a:pPr>
+            <a:r>
+              <a:t>Um Instrumento Transparente e Auditável</a:t>
             </a:r>
           </a:p>
           <a:p>
@@ -6151,121 +6996,332 @@
               <a:spcBef>
                 <a:spcPts val="800"/>
               </a:spcBef>
-              <a:defRPr sz="2500" b="1">
+            </a:pPr>
+            <a:r>
+              <a:rPr b="1" sz="1050">
+                <a:solidFill>
+                  <a:srgbClr val="10B981"/>
+                </a:solidFill>
+              </a:rPr>
+              <a:t>• Viabilidade Operacional: </a:t>
+            </a:r>
+            <a:r>
+              <a:rPr sz="1000">
+                <a:solidFill>
+                  <a:srgbClr val="CBD5E1"/>
+                </a:solidFill>
+              </a:rPr>
+              <a:t>A estratégia híbrida mitiga os custos logísticos de campo em ~80%, tornando viável a validação de modelos de predição no mestrado.</a:t>
+            </a:r>
+          </a:p>
+          <a:p>
+            <a:pPr>
+              <a:spcBef>
+                <a:spcPts val="800"/>
+              </a:spcBef>
+            </a:pPr>
+            <a:r>
+              <a:rPr b="1" sz="1050">
+                <a:solidFill>
+                  <a:srgbClr val="10B981"/>
+                </a:solidFill>
+              </a:rPr>
+              <a:t>• Ruptura com o Dado Presumido: </a:t>
+            </a:r>
+            <a:r>
+              <a:rPr sz="1000">
+                <a:solidFill>
+                  <a:srgbClr val="CBD5E1"/>
+                </a:solidFill>
+              </a:rPr>
+              <a:t>O SAREL substitui suposições por proveniência formal (medido, modelado, tabelado, indisponível).</a:t>
+            </a:r>
+          </a:p>
+          <a:p>
+            <a:pPr>
+              <a:spcBef>
+                <a:spcPts val="800"/>
+              </a:spcBef>
+            </a:pPr>
+            <a:r>
+              <a:rPr b="1" sz="1050">
+                <a:solidFill>
+                  <a:srgbClr val="10B981"/>
+                </a:solidFill>
+              </a:rPr>
+              <a:t>• Rigor em Ciência de Dados: </a:t>
+            </a:r>
+            <a:r>
+              <a:rPr sz="1000">
+                <a:solidFill>
+                  <a:srgbClr val="CBD5E1"/>
+                </a:solidFill>
+              </a:rPr>
+              <a:t>Estratificação multivariada, rarefação espacial, validação espacial LOCO e explicabilidade SHAP alinham a pesquisa à literatura contemporânea.</a:t>
+            </a:r>
+          </a:p>
+          <a:p>
+            <a:pPr>
+              <a:spcBef>
+                <a:spcPts val="800"/>
+              </a:spcBef>
+            </a:pPr>
+            <a:r>
+              <a:rPr b="1" sz="1050">
+                <a:solidFill>
+                  <a:srgbClr val="10B981"/>
+                </a:solidFill>
+              </a:rPr>
+              <a:t>• Prontidão Instrumental: </a:t>
+            </a:r>
+            <a:r>
+              <a:rPr sz="1000">
+                <a:solidFill>
+                  <a:srgbClr val="CBD5E1"/>
+                </a:solidFill>
+              </a:rPr>
+              <a:t>Arquitetura com 35 arquivos de teste e 235 asserções automatizadas garantindo o cumprimento das travas e dos invariantes.</a:t>
+            </a:r>
+          </a:p>
+        </p:txBody>
+      </p:sp>
+      <p:sp>
+        <p:nvSpPr>
+          <p:cNvPr id="3" name="Rounded Rectangle 2"/>
+          <p:cNvSpPr/>
+          <p:nvPr/>
+        </p:nvSpPr>
+        <p:spPr>
+          <a:xfrm>
+            <a:off x="6583680" y="1005840"/>
+            <a:ext cx="4846320" cy="5120640"/>
+          </a:xfrm>
+          <a:prstGeom prst="roundRect">
+            <a:avLst/>
+          </a:prstGeom>
+          <a:solidFill>
+            <a:srgbClr val="1E293B"/>
+          </a:solidFill>
+          <a:ln>
+            <a:solidFill>
+              <a:srgbClr val="065F46"/>
+            </a:solidFill>
+          </a:ln>
+        </p:spPr>
+        <p:style>
+          <a:lnRef idx="1">
+            <a:schemeClr val="accent1"/>
+          </a:lnRef>
+          <a:fillRef idx="3">
+            <a:schemeClr val="accent1"/>
+          </a:fillRef>
+          <a:effectRef idx="2">
+            <a:schemeClr val="accent1"/>
+          </a:effectRef>
+          <a:fontRef idx="minor">
+            <a:schemeClr val="lt1"/>
+          </a:fontRef>
+        </p:style>
+        <p:txBody>
+          <a:bodyPr rtlCol="0" anchor="ctr"/>
+          <a:lstStyle/>
+          <a:p>
+            <a:pPr algn="ctr"/>
+          </a:p>
+        </p:txBody>
+      </p:sp>
+      <p:sp>
+        <p:nvSpPr>
+          <p:cNvPr id="4" name="TextBox 3"/>
+          <p:cNvSpPr txBox="1"/>
+          <p:nvPr/>
+        </p:nvSpPr>
+        <p:spPr>
+          <a:xfrm>
+            <a:off x="6766560" y="1143000"/>
+            <a:ext cx="4480560" cy="4846320"/>
+          </a:xfrm>
+          <a:prstGeom prst="rect">
+            <a:avLst/>
+          </a:prstGeom>
+          <a:noFill/>
+        </p:spPr>
+        <p:txBody>
+          <a:bodyPr wrap="square">
+            <a:spAutoFit/>
+          </a:bodyPr>
+          <a:lstStyle/>
+          <a:p>
+            <a:pPr>
+              <a:defRPr sz="1100" b="1">
+                <a:solidFill>
+                  <a:srgbClr val="10B981"/>
+                </a:solidFill>
+              </a:defRPr>
+            </a:pPr>
+            <a:r>
+              <a:t>REFERÊNCIAS BIBLIOGRÁFICAS CANÔNICAS</a:t>
+            </a:r>
+          </a:p>
+          <a:p>
+            <a:pPr>
+              <a:spcBef>
+                <a:spcPts val="400"/>
+              </a:spcBef>
+            </a:pPr>
+            <a:r>
+              <a:rPr b="1" sz="850">
                 <a:solidFill>
                   <a:srgbClr val="FFFFFF"/>
                 </a:solidFill>
-              </a:defRPr>
-            </a:pPr>
-            <a:r>
-              <a:t>Um Instrumento Computacional Ético, Auditável e Replicável</a:t>
+              </a:rPr>
+              <a:t>• Renard et al. (1997): </a:t>
+            </a:r>
+            <a:r>
+              <a:rPr sz="800">
+                <a:solidFill>
+                  <a:srgbClr val="CBD5E1"/>
+                </a:solidFill>
+              </a:rPr>
+              <a:t>Predicting soil erosion by water: a guide to conservation planning with RUSLE. USDA Agricultural Handbook 703.</a:t>
             </a:r>
           </a:p>
           <a:p>
             <a:pPr>
               <a:spcBef>
-                <a:spcPts val="1000"/>
+                <a:spcPts val="400"/>
               </a:spcBef>
             </a:pPr>
             <a:r>
-              <a:rPr b="1" sz="1150">
-                <a:solidFill>
-                  <a:srgbClr val="10B981"/>
-                </a:solidFill>
-              </a:rPr>
-              <a:t>• Viabilidade Prática Comprovada: </a:t>
-            </a:r>
-            <a:r>
-              <a:rPr sz="1100">
+              <a:rPr b="1" sz="850">
+                <a:solidFill>
+                  <a:srgbClr val="FFFFFF"/>
+                </a:solidFill>
+              </a:rPr>
+              <a:t>• Durigon et al. (2014): </a:t>
+            </a:r>
+            <a:r>
+              <a:rPr sz="800">
                 <a:solidFill>
                   <a:srgbClr val="CBD5E1"/>
                 </a:solidFill>
               </a:rPr>
-              <a:t>A estratégia híbrida reduz os custos operacionais de amostragem em ~80%, tornando viável a validação de modelos de IA para conservação de solos no mestrado.</a:t>
+              <a:t>NDVI-based C-factor estimation for RUSLE in Brazilian watersheds. Brazilian Journal of Soil Science, 38(3).</a:t>
             </a:r>
           </a:p>
           <a:p>
             <a:pPr>
               <a:spcBef>
-                <a:spcPts val="1000"/>
+                <a:spcPts val="400"/>
               </a:spcBef>
             </a:pPr>
             <a:r>
-              <a:rPr b="1" sz="1150">
-                <a:solidFill>
-                  <a:srgbClr val="10B981"/>
-                </a:solidFill>
-              </a:rPr>
-              <a:t>• Ruptura com o Dado Presumido: </a:t>
-            </a:r>
-            <a:r>
-              <a:rPr sz="1100">
+              <a:rPr b="1" sz="850">
+                <a:solidFill>
+                  <a:srgbClr val="FFFFFF"/>
+                </a:solidFill>
+              </a:rPr>
+              <a:t>• Zhu &amp; Woodcock (2014): </a:t>
+            </a:r>
+            <a:r>
+              <a:rPr sz="800">
                 <a:solidFill>
                   <a:srgbClr val="CBD5E1"/>
                 </a:solidFill>
               </a:rPr>
-              <a:t>O SAREL encerra a era dos valores fabricados por atalhos computacionais. O sistema prefere declarar a ausência a exibir uma medição ilusória à banca.</a:t>
+              <a:t>Continuous change detection and classification of land cover using all available Landsat data. Remote Sensing of Environment.</a:t>
             </a:r>
           </a:p>
           <a:p>
             <a:pPr>
               <a:spcBef>
-                <a:spcPts val="1000"/>
+                <a:spcPts val="400"/>
               </a:spcBef>
             </a:pPr>
             <a:r>
-              <a:rPr b="1" sz="1150">
-                <a:solidFill>
-                  <a:srgbClr val="10B981"/>
-                </a:solidFill>
-              </a:rPr>
-              <a:t>• Rigor Metodológico Internacional: </a:t>
-            </a:r>
-            <a:r>
-              <a:rPr sz="1100">
+              <a:rPr b="1" sz="850">
+                <a:solidFill>
+                  <a:srgbClr val="FFFFFF"/>
+                </a:solidFill>
+              </a:rPr>
+              <a:t>• Landis &amp; Koch (1977): </a:t>
+            </a:r>
+            <a:r>
+              <a:rPr sz="800">
                 <a:solidFill>
                   <a:srgbClr val="CBD5E1"/>
                 </a:solidFill>
               </a:rPr>
-              <a:t>Estratificação multivariada, Thinning Geodésico, validação cruzada espacial LOCO e explicabilidade SHAP alinham a pesquisa às melhores práticas da literatura de sensoriamento remoto.</a:t>
+              <a:t>The measurement of observer agreement for categorical data. Biometrics, 33(1), 159-174.</a:t>
             </a:r>
           </a:p>
           <a:p>
             <a:pPr>
               <a:spcBef>
-                <a:spcPts val="1000"/>
+                <a:spcPts val="400"/>
               </a:spcBef>
             </a:pPr>
             <a:r>
-              <a:rPr b="1" sz="1150">
-                <a:solidFill>
-                  <a:srgbClr val="10B981"/>
-                </a:solidFill>
-              </a:rPr>
-              <a:t>• Prontidão para a Campanha Real: </a:t>
-            </a:r>
-            <a:r>
-              <a:rPr sz="1100">
+              <a:rPr b="1" sz="850">
+                <a:solidFill>
+                  <a:srgbClr val="FFFFFF"/>
+                </a:solidFill>
+              </a:rPr>
+              <a:t>• Roberts et al. (2017): </a:t>
+            </a:r>
+            <a:r>
+              <a:rPr sz="800">
                 <a:solidFill>
                   <a:srgbClr val="CBD5E1"/>
                 </a:solidFill>
               </a:rPr>
-              <a:t>A infraestrutura computacional (Next.js, TypeScript, Python, SQLite e GEE) está 100% testada e homologada, pronta para a execução da campanha de campo e fotointerpretação.</a:t>
+              <a:t>Cross-validation strategies for data with temporal, spatial, or hierarchical structure. Ecography, 40(8).</a:t>
             </a:r>
           </a:p>
           <a:p>
             <a:pPr>
               <a:spcBef>
-                <a:spcPts val="2400"/>
+                <a:spcPts val="400"/>
               </a:spcBef>
-              <a:defRPr sz="1050" b="1">
-                <a:solidFill>
-                  <a:srgbClr val="0EA5E9"/>
-                </a:solidFill>
-              </a:defRPr>
-            </a:pPr>
-            <a:r>
-              <a:t>PPGTCA 2026 • Pesquisador: Luis Alfredo • Programa de Pós-Graduação em Tecnologias Computacionais para o Agronegócio</a:t>
+            </a:pPr>
+            <a:r>
+              <a:rPr b="1" sz="850">
+                <a:solidFill>
+                  <a:srgbClr val="FFFFFF"/>
+                </a:solidFill>
+              </a:rPr>
+              <a:t>• Tobler (1970): </a:t>
+            </a:r>
+            <a:r>
+              <a:rPr sz="800">
+                <a:solidFill>
+                  <a:srgbClr val="CBD5E1"/>
+                </a:solidFill>
+              </a:rPr>
+              <a:t>A computer movie simulating urban growth in the Detroit region. Economic Geography, 46(sup1).</a:t>
+            </a:r>
+          </a:p>
+          <a:p>
+            <a:pPr>
+              <a:spcBef>
+                <a:spcPts val="400"/>
+              </a:spcBef>
+            </a:pPr>
+            <a:r>
+              <a:rPr b="1" sz="850">
+                <a:solidFill>
+                  <a:srgbClr val="FFFFFF"/>
+                </a:solidFill>
+              </a:rPr>
+              <a:t>• Lundberg &amp; Lee (2017): </a:t>
+            </a:r>
+            <a:r>
+              <a:rPr sz="800">
+                <a:solidFill>
+                  <a:srgbClr val="CBD5E1"/>
+                </a:solidFill>
+              </a:rPr>
+              <a:t>A unified approach to interpreting model predictions. Advances in Neural Information Processing Systems (NeurIPS).</a:t>
             </a:r>
           </a:p>
         </p:txBody>
@@ -6399,7 +7455,7 @@
           <a:lstStyle/>
           <a:p>
             <a:pPr>
-              <a:defRPr sz="2200" b="1">
+              <a:defRPr sz="2100" b="1">
                 <a:solidFill>
                   <a:srgbClr val="FFFFFF"/>
                 </a:solidFill>
@@ -6584,7 +7640,7 @@
                   <a:srgbClr val="0F172A"/>
                 </a:solidFill>
               </a:rPr>
-              <a:t>Processo Invisível: </a:t>
+              <a:t>Processo Difuso: </a:t>
             </a:r>
             <a:r>
               <a:rPr sz="1019">
@@ -6615,7 +7671,7 @@
                   <a:srgbClr val="475569"/>
                 </a:solidFill>
               </a:rPr>
-              <a:t>Toneladas de matéria orgânica, fertilizantes e argila são carreadas aos rios muito antes do dano ser percebido visualmente.</a:t>
+              <a:t>Perda contínua de matéria orgânica, nutrientes minerais e redução da capacidade de infiltração hídrica do solo.</a:t>
             </a:r>
           </a:p>
           <a:p>
@@ -6638,7 +7694,7 @@
                   <a:srgbClr val="475569"/>
                 </a:solidFill>
               </a:rPr>
-              <a:t>O Estado do Paraná possui 199.315 km² de área, exigindo ferramentas capazes de monitorar bacias inteiras em macroescala.</a:t>
+              <a:t>O Estado do Paraná possui 199.315 km² de área, exigindo ferramentas capazes de monitorar bacias hidrográficas inteiras.</a:t>
             </a:r>
           </a:p>
         </p:txBody>
@@ -6744,7 +7800,7 @@
                   <a:srgbClr val="475569"/>
                 </a:solidFill>
               </a:rPr>
-              <a:t>Inspeções de campo convencionais cobrem áreas restritas, são lentas e enviesadas por proximidade a rodovias e estradas.</a:t>
+              <a:t>Inspeções convencionais de campo cobrem áreas restritas, são lentas e sujeitas a viés de proximidade rodoviária.</a:t>
             </a:r>
           </a:p>
           <a:p>
@@ -6767,7 +7823,7 @@
                   <a:srgbClr val="475569"/>
                 </a:solidFill>
               </a:rPr>
-              <a:t>Planilhas manuais não registram a proveniência dos dados nem a data exata da imagem satelital que embasou o laudo.</a:t>
+              <a:t>Planilhas sem rastreamento de proveniência, produto orbital ou data exata da imagem que embasou a rotulagem.</a:t>
             </a:r>
           </a:p>
           <a:p>
@@ -6790,7 +7846,7 @@
                   <a:srgbClr val="475569"/>
                 </a:solidFill>
               </a:rPr>
-              <a:t>Percorrer centenas de municípios paranaenses demanda tempo e recursos financeiros proibitivos para a pesquisa.</a:t>
+              <a:t>Percorrer centenas de municípios paranaenses demanda tempo e recursos financeiros incompatíveis com a pós-graduação.</a:t>
             </a:r>
           </a:p>
         </p:txBody>
@@ -6896,7 +7952,7 @@
                   <a:srgbClr val="475569"/>
                 </a:solidFill>
               </a:rPr>
-              <a:t>Algoritmo computacional que varre o território paranaense elegendo amostras estatisticamente balanceadas.</a:t>
+              <a:t>Algoritmo computacional que varre o território estadual elegendo amostras balanceadas em relevo, solo e histórico.</a:t>
             </a:r>
           </a:p>
           <a:p>
@@ -6919,7 +7975,7 @@
                   <a:srgbClr val="475569"/>
                 </a:solidFill>
               </a:rPr>
-              <a:t>Integração do Google Earth Engine (Sentinel-2), Copernicus DEM, cartas oficiais da Embrapa e malhas do CAR.</a:t>
+              <a:t>Integração do Google Earth Engine (Sentinel-2), Copernicus DEM, cartas oficiais da Embrapa e malha do CAR.</a:t>
             </a:r>
           </a:p>
           <a:p>
@@ -6934,7 +7990,7 @@
                   <a:srgbClr val="0F172A"/>
                 </a:solidFill>
               </a:rPr>
-              <a:t>Rigor Científico Total: </a:t>
+              <a:t>Transparência Metodológica: </a:t>
             </a:r>
             <a:r>
               <a:rPr sz="1019">
@@ -6942,7 +7998,7 @@
                   <a:srgbClr val="475569"/>
                 </a:solidFill>
               </a:rPr>
-              <a:t>Separação estrita entre observação e modelagem, garantindo blindagem metodológica perante a banca do PPGTCA.</a:t>
+              <a:t>Separação rigorosa entre amostragem e predição, garantindo reprodutibilidade acadêmica perante a banca.</a:t>
             </a:r>
           </a:p>
         </p:txBody>
@@ -7076,14 +8132,14 @@
           <a:lstStyle/>
           <a:p>
             <a:pPr>
-              <a:defRPr sz="2200" b="1">
+              <a:defRPr sz="2100" b="1">
                 <a:solidFill>
                   <a:srgbClr val="FFFFFF"/>
                 </a:solidFill>
               </a:defRPr>
             </a:pPr>
             <a:r>
-              <a:t>Viabilidade Econômica: O Dilema de Custos de Amostragem</a:t>
+              <a:t>Viabilidade Metodológica: O Dilema de Custos de Amostragem</a:t>
             </a:r>
           </a:p>
         </p:txBody>
@@ -7243,12 +8299,12 @@
               </a:defRPr>
             </a:pPr>
             <a:r>
-              <a:t>100% CAMPO (INVIÁVEL)</a:t>
+              <a:t>100% CAMPO (ORÇAMENTO ELEVADO)</a:t>
             </a:r>
           </a:p>
           <a:p>
             <a:pPr algn="ctr">
-              <a:defRPr sz="1700" b="1">
+              <a:defRPr sz="1600" b="1">
                 <a:solidFill>
                   <a:srgbClr val="E11D48"/>
                 </a:solidFill>
@@ -7335,12 +8391,12 @@
               </a:defRPr>
             </a:pPr>
             <a:r>
-              <a:t>100% SINTÉTICO (VICIADO)</a:t>
+              <a:t>100% SINTÉTICO (VÍCIO CIENTÍFICO)</a:t>
             </a:r>
           </a:p>
           <a:p>
             <a:pPr algn="ctr">
-              <a:defRPr sz="1700" b="1">
+              <a:defRPr sz="1600" b="1">
                 <a:solidFill>
                   <a:srgbClr val="D97706"/>
                 </a:solidFill>
@@ -7432,14 +8488,14 @@
           </a:p>
           <a:p>
             <a:pPr algn="ctr">
-              <a:defRPr sz="1700" b="1">
+              <a:defRPr sz="1600" b="1">
                 <a:solidFill>
                   <a:srgbClr val="10B981"/>
                 </a:solidFill>
               </a:defRPr>
             </a:pPr>
             <a:r>
-              <a:t>Economia ~80% (Custo Exequível)</a:t>
+              <a:t>Estimativa ~80% redução operacional</a:t>
             </a:r>
           </a:p>
         </p:txBody>
@@ -7545,7 +8601,7 @@
                   <a:srgbClr val="475569"/>
                 </a:solidFill>
               </a:rPr>
-              <a:t>Visita presencial a 250-300 pontos dispersos por todo o Paraná.</a:t>
+              <a:t>Visita presencial a centenas de pontos dispersos por todo o Estado do Paraná.</a:t>
             </a:r>
           </a:p>
           <a:p>
@@ -7568,7 +8624,7 @@
                   <a:srgbClr val="475569"/>
                 </a:solidFill>
               </a:rPr>
-              <a:t>Combustível, veículos 4x4, diárias de equipe, aluguel de GNSS RTK e 4 a 6 meses de deslocamento contínuo.</a:t>
+              <a:t>Combustível, veículos com tração integral, diárias de equipe, receptores GNSS de precisão e meses de viagem.</a:t>
             </a:r>
           </a:p>
           <a:p>
@@ -7583,7 +8639,7 @@
                   <a:srgbClr val="0F172A"/>
                 </a:solidFill>
               </a:rPr>
-              <a:t>Risco Acadêmico: </a:t>
+              <a:t>Risco Metodológico: </a:t>
             </a:r>
             <a:r>
               <a:rPr sz="1000">
@@ -7591,7 +8647,7 @@
                   <a:srgbClr val="475569"/>
                 </a:solidFill>
               </a:rPr>
-              <a:t>Amostra insuficiente (N &lt; 40 pontos) devido ao orçamento, gerando subajuste (underfitting) no classificador XGBoost.</a:t>
+              <a:t>Amostra insuficiente (N &lt; 40 pontos) devido ao orçamento, gerando alta variância e sobreajuste (overfitting) em árvores de decisão.</a:t>
             </a:r>
           </a:p>
         </p:txBody>
@@ -7689,7 +8745,7 @@
                   <a:srgbClr val="0F172A"/>
                 </a:solidFill>
               </a:rPr>
-              <a:t>Atalho Computacional: </a:t>
+              <a:t>Atalho Metodológico: </a:t>
             </a:r>
             <a:r>
               <a:rPr sz="1000">
@@ -7697,7 +8753,7 @@
                   <a:srgbClr val="475569"/>
                 </a:solidFill>
               </a:rPr>
-              <a:t>Gerar dados de erosão e solo a partir de fórmulas matemáticas (RUSLE) ou simulações aleatórias sem checagem empírica.</a:t>
+              <a:t>Gerar dados de erosão a partir de fórmulas matemáticas (RUSLE) ou simulações estatísticas sem ancoragem empírica.</a:t>
             </a:r>
           </a:p>
           <a:p>
@@ -7712,7 +8768,7 @@
                   <a:srgbClr val="0F172A"/>
                 </a:solidFill>
               </a:rPr>
-              <a:t>Vício Científico: </a:t>
+              <a:t>Vício de Circularidade: </a:t>
             </a:r>
             <a:r>
               <a:rPr sz="1000">
@@ -7720,7 +8776,7 @@
                   <a:srgbClr val="475569"/>
                 </a:solidFill>
               </a:rPr>
-              <a:t>O modelo de IA apenas memoriza as equações que o próprio pesquisador inseriu (vazamento de alvo / overfitting trivial).</a:t>
+              <a:t>O modelo de aprendizado de máquina apenas reproduz as equações fornecidas pelo pesquisador (vazamento de alvo / circularidade).</a:t>
             </a:r>
           </a:p>
           <a:p>
@@ -7743,7 +8799,7 @@
                   <a:srgbClr val="475569"/>
                 </a:solidFill>
               </a:rPr>
-              <a:t>Desqualificação imediata perante a banca examinadora por ausência de dados empíricos observacionais.</a:t>
+              <a:t>Desqualificação perante a banca examinadora por ausência de dados empíricos observacionais.</a:t>
             </a:r>
           </a:p>
         </p:txBody>
@@ -7841,7 +8897,7 @@
                   <a:srgbClr val="0F172A"/>
                 </a:solidFill>
               </a:rPr>
-              <a:t>Desenho Otimizado: </a:t>
+              <a:t>Triagem Otimizada: </a:t>
             </a:r>
             <a:r>
               <a:rPr sz="1000">
@@ -7849,7 +8905,7 @@
                   <a:srgbClr val="475569"/>
                 </a:solidFill>
               </a:rPr>
-              <a:t>Triagem no Earth Engine + Fotointerpretação em Alta Resolução (PlanetScope/VHR) para 80% do dataset.</a:t>
+              <a:t>Extração no Earth Engine + Fotointerpretação em Alta Resolução (PlanetScope/VHR) para a maior parte do conjunto.</a:t>
             </a:r>
           </a:p>
           <a:p>
@@ -7872,7 +8928,7 @@
                   <a:srgbClr val="475569"/>
                 </a:solidFill>
               </a:rPr>
-              <a:t>Subamostra de controle (20%) em campo com KoboToolbox, GNSS RTK e ortomosaicos de drone.</a:t>
+              <a:t>Subamostra de controle (20%) em campo com formulário KoboToolbox, GNSS submétrico e ortomosaicos de drone.</a:t>
             </a:r>
           </a:p>
           <a:p>
@@ -7895,7 +8951,7 @@
                   <a:srgbClr val="475569"/>
                 </a:solidFill>
               </a:rPr>
-              <a:t>Matriz de Confusão e Índice Kappa de Cohen (κ ≥ 0,60) medindo e compensando formalmente a taxa de erro humana.</a:t>
+              <a:t>Matriz de Confusão e Índice Kappa de Cohen (κ ≥ 0,61) com IC 95% medindo a concordância inter-observadores.</a:t>
             </a:r>
           </a:p>
         </p:txBody>
@@ -8029,7 +9085,7 @@
           <a:lstStyle/>
           <a:p>
             <a:pPr>
-              <a:defRPr sz="2200" b="1">
+              <a:defRPr sz="2100" b="1">
                 <a:solidFill>
                   <a:srgbClr val="FFFFFF"/>
                 </a:solidFill>
@@ -8260,7 +9316,7 @@
                   <a:srgbClr val="0F172A"/>
                 </a:solidFill>
               </a:rPr>
-              <a:t>• Garante formalmente a inclusão de candidatos à classe de controle (Sistema Plantio Direto e pastagem estável). </a:t>
+              <a:t>• Garante formalmente a inclusão de candidatos à classe de controle (Plantio Direto e pastagem estável). </a:t>
             </a:r>
             <a:r>
               <a:rPr sz="980">
@@ -8283,7 +9339,7 @@
                   <a:srgbClr val="0F172A"/>
                 </a:solidFill>
               </a:rPr>
-              <a:t>• Aplica Thinning Geodésico (raio ≥ 1,0 km) para impedir agrupamentos espaciais e pseudorrepetição amostral. </a:t>
+              <a:t>• Aplica Thinning Geodésico (raio ≥ 1,0 km) para mitigar agrupamentos e pseudorrepetição espacial. </a:t>
             </a:r>
             <a:r>
               <a:rPr sz="980">
@@ -8374,7 +9430,7 @@
               </a:defRPr>
             </a:pPr>
             <a:r>
-              <a:t>2. Extrai Features Verificáveis</a:t>
+              <a:t>2. Extrai Preditores Biofísicos</a:t>
             </a:r>
           </a:p>
           <a:p>
@@ -8412,7 +9468,7 @@
                   <a:srgbClr val="0F172A"/>
                 </a:solidFill>
               </a:rPr>
-              <a:t>• Coleta séries temporais harmonizadas Sentinel-2 L2A (10 anos) e extrai métricas de exposição de solo nu (Ê). </a:t>
+              <a:t>• Coleta séries temporais harmonizadas Sentinel-2 L2A e extrai métricas de exposição de solo descoberto (Ê). </a:t>
             </a:r>
             <a:r>
               <a:rPr sz="980">
@@ -8458,7 +9514,7 @@
                   <a:srgbClr val="0F172A"/>
                 </a:solidFill>
               </a:rPr>
-              <a:t>• Consulta pedologia real via WMS OGC no GeoServer da Embrapa Solos, sem classes inventadas. </a:t>
+              <a:t>• Consulta pedologia real via WFS/WMS OGC no GeoServer da Embrapa Solos, sem classes arbitrárias. </a:t>
             </a:r>
             <a:r>
               <a:rPr sz="980">
@@ -8564,7 +9620,7 @@
                   <a:srgbClr val="0F172A"/>
                 </a:solidFill>
               </a:rPr>
-              <a:t>Campanhas de Validação e Matriz de Treino </a:t>
+              <a:t>Campanhas de Curadoria e Matriz de Treino </a:t>
             </a:r>
             <a:r>
               <a:rPr sz="980">
@@ -8587,7 +9643,7 @@
                   <a:srgbClr val="0F172A"/>
                 </a:solidFill>
               </a:rPr>
-              <a:t>• Exporta cadernos cegos de fotointerpretação, campo (KoboToolbox) e voo de drone, blindando o intérprete. </a:t>
+              <a:t>• Exporta cadernos cegos de fotointerpretação, campo (KoboToolbox) e voo de drone, isolando o intérprete. </a:t>
             </a:r>
             <a:r>
               <a:rPr sz="980">
@@ -8610,7 +9666,7 @@
                   <a:srgbClr val="0F172A"/>
                 </a:solidFill>
               </a:rPr>
-              <a:t>• Avalia a concordância inter-observador via Kappa de Cohen com alerta bloqueante para κ &lt; 0,60. </a:t>
+              <a:t>• Avalia a concordância inter-observador via Kappa de Cohen com cálculo de IC 95% e alerta bloqueante. </a:t>
             </a:r>
             <a:r>
               <a:rPr sz="980">
@@ -8633,7 +9689,7 @@
                   <a:srgbClr val="0F172A"/>
                 </a:solidFill>
               </a:rPr>
-              <a:t>• Monta a matriz de treino do XGBoost livre de coordenadas e de variáveis calculadas pelo próprio sistema. </a:t>
+              <a:t>• Monta a matriz de treino do modelo preditivo livre de coordenadas e de variáveis de resultado calculadas. </a:t>
             </a:r>
             <a:r>
               <a:rPr sz="980">
@@ -8733,7 +9789,7 @@
               </a:defRPr>
             </a:pPr>
             <a:r>
-              <a:t>O SAREL NÃO classifica erosão e NÃO treina a IA dentro de si. Ele prepara o chão experimental honesto e auditável. O rótulo vem exclusivamente de observadores humanos. O treinamento do XGBoost ocorre externamente.</a:t>
+              <a:t>O SAREL NÃO classifica erosão de forma autônoma e NÃO treina modelos preditivos em seu interior. Ele prepara a base amostral auditável e gerencia a rotulagem cega. O rótulo é atribuído exclusivamente por especialistas humanos. O treinamento do XGBoost ocorre externamente.</a:t>
             </a:r>
           </a:p>
         </p:txBody>
@@ -8839,7 +9895,7 @@
               </a:defRPr>
             </a:pPr>
             <a:r>
-              <a:t>GOVERNANÇA METODOLÓGICA &amp; INTEGRIDADE</a:t>
+              <a:t>GOVERNANÇA METODOLÓGICA &amp; INTEGRIDADE DE DADOS</a:t>
             </a:r>
           </a:p>
         </p:txBody>
@@ -8867,14 +9923,14 @@
           <a:lstStyle/>
           <a:p>
             <a:pPr>
-              <a:defRPr sz="2200" b="1">
+              <a:defRPr sz="2100" b="1">
                 <a:solidFill>
                   <a:srgbClr val="FFFFFF"/>
                 </a:solidFill>
               </a:defRPr>
             </a:pPr>
             <a:r>
-              <a:t>A Lei Fundamental do SAREL: Blindagem Pericial Contra Atalhos</a:t>
+              <a:t>A Lei Fundamental do SAREL: Governança Contra Atalhos Metodológicos</a:t>
             </a:r>
           </a:p>
         </p:txBody>
@@ -9052,7 +10108,7 @@
                   <a:srgbClr val="0F172A"/>
                 </a:solidFill>
               </a:rPr>
-              <a:t>Proibição de Constantes: </a:t>
+              <a:t>Vedação a Constantes: </a:t>
             </a:r>
             <a:r>
               <a:rPr sz="1000">
@@ -9060,7 +10116,7 @@
                   <a:srgbClr val="475569"/>
                 </a:solidFill>
               </a:rPr>
-              <a:t>Terminantemente vedado preencher lacunas com médias ou constantes arbitrárias (ex.: unmask numérico ou defaults em cascata).</a:t>
+              <a:t>Proibido preencher lacunas com médias ou constantes arbitrárias em cascata sem base empírica.</a:t>
             </a:r>
           </a:p>
           <a:p>
@@ -9083,7 +10139,7 @@
                   <a:srgbClr val="475569"/>
                 </a:solidFill>
               </a:rPr>
-              <a:t>O XGBoost lida com ausência de dados nativamente. Ausente é tecnicamente superior a dado fabricado.</a:t>
+              <a:t>Algoritmos modernos tratam valores faltantes nativamente. Ausente é cientificamente preferível a dado fabricado.</a:t>
             </a:r>
           </a:p>
           <a:p>
@@ -9098,7 +10154,7 @@
                   <a:srgbClr val="0F172A"/>
                 </a:solidFill>
               </a:rPr>
-              <a:t>Zero é Valor: </a:t>
+              <a:t>Zero é Valor Físico: </a:t>
             </a:r>
             <a:r>
               <a:rPr sz="1000">
@@ -9106,7 +10162,7 @@
                   <a:srgbClr val="475569"/>
                 </a:solidFill>
               </a:rPr>
-              <a:t>Declividade 0% ou Ê = 0 são valores físicos legítimos, nunca tratados como ausência.</a:t>
+              <a:t>Declividade 0% ou frequência Ê = 0 são grandezas físicas reais, nunca tratadas como ausência de dados.</a:t>
             </a:r>
           </a:p>
         </p:txBody>
@@ -9189,7 +10245,7 @@
               </a:defRPr>
             </a:pPr>
             <a:r>
-              <a:t>Regra 3: Proveniência Viaja Junto com o Valor</a:t>
+              <a:t>Regra 3: Proveniência Vinculada a Cada Valor</a:t>
             </a:r>
           </a:p>
           <a:p>
@@ -9212,7 +10268,7 @@
                   <a:srgbClr val="475569"/>
                 </a:solidFill>
               </a:rPr>
-              <a:t>Todo valor numérico é acompanhado de estado, fonte primária oficial e data de aquisição.</a:t>
+              <a:t>Cada atributo carrega seu status de proveniência, fonte oficial de aquisição e data.</a:t>
             </a:r>
           </a:p>
           <a:p>
@@ -9235,7 +10291,7 @@
                   <a:srgbClr val="475569"/>
                 </a:solidFill>
               </a:rPr>
-              <a:t>● medido (sensor primário) • ◊ modelado (equação) • □ tabelado (literatura) • ○ indisponível.</a:t>
+              <a:t>● medido (sensor primário) • ◊ modelado (equação validada) • □ tabelado (literatura) • ○ indisponível.</a:t>
             </a:r>
           </a:p>
           <a:p>
@@ -9258,7 +10314,7 @@
                   <a:srgbClr val="475569"/>
                 </a:solidFill>
               </a:rPr>
-              <a:t>Possibilita reconstruir a cadeia de evidências de cada linha perante a banca.</a:t>
+              <a:t>Permite reconstruir a cadeia de custódia e evidências de cada linha exportada perante a banca.</a:t>
             </a:r>
           </a:p>
         </p:txBody>
@@ -9341,7 +10397,7 @@
               </a:defRPr>
             </a:pPr>
             <a:r>
-              <a:t>Regra 4: Nada Calculado Vira Rótulo</a:t>
+              <a:t>Regra 4: Isolamento Estrito Contra Circularidade</a:t>
             </a:r>
           </a:p>
           <a:p>
@@ -9364,7 +10420,7 @@
                   <a:srgbClr val="475569"/>
                 </a:solidFill>
               </a:rPr>
-              <a:t>Scores internos, severidade estimada ou perda RUSLE nunca viram rótulo de treino.</a:t>
+              <a:t>Scores intermediários, severidade estimada ou perda de solo RUSLE não integram a matriz de treino.</a:t>
             </a:r>
           </a:p>
           <a:p>
@@ -9387,7 +10443,7 @@
                   <a:srgbClr val="475569"/>
                 </a:solidFill>
               </a:rPr>
-              <a:t>Evita que a IA aprenda limiares artificiais das fórmulas em vez de padrões reais da paisagem.</a:t>
+              <a:t>Impede que o classificador aprenda limiares matemáticos artificiais em vez de padrões espectro-temporais.</a:t>
             </a:r>
           </a:p>
           <a:p>
@@ -9410,7 +10466,7 @@
                   <a:srgbClr val="475569"/>
                 </a:solidFill>
               </a:rPr>
-              <a:t>A classe alvo deriva unicamente de inspeção de campo, fotointerpretação ou drone.</a:t>
+              <a:t>A classe alvo deriva unicamente de inspeção presencial de campo, ortomosaicos de drone ou fotointerpretação.</a:t>
             </a:r>
           </a:p>
         </p:txBody>
@@ -9493,7 +10549,7 @@
               </a:defRPr>
             </a:pPr>
             <a:r>
-              <a:t>Regra 9: Governança de Decisões (DECISOES.md)</a:t>
+              <a:t>Regra 9: Registro Formal de Decisões (DECISOES.md)</a:t>
             </a:r>
           </a:p>
           <a:p>
@@ -9508,7 +10564,7 @@
                   <a:srgbClr val="0F172A"/>
                 </a:solidFill>
               </a:rPr>
-              <a:t>Dono do Parâmetro: </a:t>
+              <a:t>Atribuição de Parâmetros: </a:t>
             </a:r>
             <a:r>
               <a:rPr sz="1000">
@@ -9516,7 +10572,7 @@
                   <a:srgbClr val="475569"/>
                 </a:solidFill>
               </a:rPr>
-              <a:t>Nenhum limiar, peso ou corte nasce como literal no código sem autor, data e referência bibliográfica.</a:t>
+              <a:t>Nenhum limiar ou equação é inserido no código sem autor responsável, data e referência bibliográfica canônica.</a:t>
             </a:r>
           </a:p>
           <a:p>
@@ -9539,7 +10595,7 @@
                   <a:srgbClr val="475569"/>
                 </a:solidFill>
               </a:rPr>
-              <a:t>Enquanto o pesquisador não decidir (ex.: D13, D14, D15), o cálculo gera 'indisponivel' com a causa.</a:t>
+              <a:t>Enquanto o pesquisador não deliberar formalmente (ex.: D13, D14, D15), o cálculo gera 'indisponivel' com justificativa.</a:t>
             </a:r>
           </a:p>
           <a:p>
@@ -9554,7 +10610,7 @@
                   <a:srgbClr val="0F172A"/>
                 </a:solidFill>
               </a:rPr>
-              <a:t>Imunidade a Arbitrariedades: </a:t>
+              <a:t>Autonomia do Pesquisador: </a:t>
             </a:r>
             <a:r>
               <a:rPr sz="1000">
@@ -9562,7 +10618,7 @@
                   <a:srgbClr val="475569"/>
                 </a:solidFill>
               </a:rPr>
-              <a:t>O agente de IA não toma decisões de dissertação no lugar do mestrando.</a:t>
+              <a:t>O sistema não toma decisões teóricas de dissertação no lugar do mestrando.</a:t>
             </a:r>
           </a:p>
         </p:txBody>
@@ -9696,14 +10752,14 @@
           <a:lstStyle/>
           <a:p>
             <a:pPr>
-              <a:defRPr sz="2200" b="1">
+              <a:defRPr sz="2100" b="1">
                 <a:solidFill>
                   <a:srgbClr val="FFFFFF"/>
                 </a:solidFill>
               </a:defRPr>
             </a:pPr>
             <a:r>
-              <a:t>Desenho Amostral: 18 Estratos Multivariados &amp; Thinning Geodésico</a:t>
+              <a:t>Desenho Amostral: 18 Estratos Multivariados &amp; Rarefação Espacial</a:t>
             </a:r>
           </a:p>
         </p:txBody>
@@ -9912,7 +10968,7 @@
                   <a:srgbClr val="475569"/>
                 </a:solidFill>
               </a:rPr>
-              <a:t>Tercis de declividade (Suave, Moderada, Forte) derivados do DEM Copernicus.</a:t>
+              <a:t>Tercis de declividade (Suave, Moderada, Forte) derivados do DEM Copernicus GLO-30.</a:t>
             </a:r>
           </a:p>
           <a:p>
@@ -9958,7 +11014,7 @@
                   <a:srgbClr val="475569"/>
                 </a:solidFill>
               </a:rPr>
-              <a:t>2 níveis de erodibilidade derivados do levantamento pedológico da Embrapa.</a:t>
+              <a:t>2 níveis de erodibilidade derivados do levantamento pedológico oficial da Embrapa Solos.</a:t>
             </a:r>
           </a:p>
         </p:txBody>
@@ -10041,7 +11097,7 @@
               </a:defRPr>
             </a:pPr>
             <a:r>
-              <a:t>2. Thinning Geodésico</a:t>
+              <a:t>2. Rarefação Espacial (Thinning)</a:t>
             </a:r>
           </a:p>
           <a:p>
@@ -10087,7 +11143,7 @@
                   <a:srgbClr val="475569"/>
                 </a:solidFill>
               </a:rPr>
-              <a:t>Pixels contíguos possuem solos e relevo similares, causando inflação artificial de acurácia.</a:t>
+              <a:t>Pixels contíguos possuem solos e relevo similares, causando inflação artificial por dependência espacial.</a:t>
             </a:r>
           </a:p>
           <a:p>
@@ -10102,7 +11158,7 @@
                   <a:srgbClr val="0F172A"/>
                 </a:solidFill>
               </a:rPr>
-              <a:t>Algoritmo Fisher-Yates: </a:t>
+              <a:t>Algoritmo Determinístico: </a:t>
             </a:r>
             <a:r>
               <a:rPr sz="1019">
@@ -10110,7 +11166,7 @@
                   <a:srgbClr val="475569"/>
                 </a:solidFill>
               </a:rPr>
-              <a:t>Espaçamento euclidiano/haversine determinístico com semente registrada (P07).</a:t>
+              <a:t>Rarefação espacial gulosa com ordenação determinística (Fisher-Yates) e semente registrada (P07).</a:t>
             </a:r>
           </a:p>
           <a:p>
@@ -10254,7 +11310,7 @@
                   <a:srgbClr val="0F172A"/>
                 </a:solidFill>
               </a:rPr>
-              <a:t>Classe 1 (Erosão): </a:t>
+              <a:t>Classe 1 (Erosão Potencial): </a:t>
             </a:r>
             <a:r>
               <a:rPr sz="1019">
@@ -10262,7 +11318,7 @@
                   <a:srgbClr val="475569"/>
                 </a:solidFill>
               </a:rPr>
-              <a:t>Candidatos estratificados com histórico de exposição e gradiente de rampa.</a:t>
+              <a:t>Candidatos estratificados com histórico de exposição frequente e gradiente de rampa.</a:t>
             </a:r>
           </a:p>
           <a:p>
@@ -10277,7 +11333,7 @@
                   <a:srgbClr val="0F172A"/>
                 </a:solidFill>
               </a:rPr>
-              <a:t>Classe 0 (Controle): </a:t>
+              <a:t>Classe 0 (Controle Negativo): </a:t>
             </a:r>
             <a:r>
               <a:rPr sz="1019">
@@ -10285,7 +11341,7 @@
                   <a:srgbClr val="475569"/>
                 </a:solidFill>
               </a:rPr>
-              <a:t>Amostragem em áreas sob Sistema Plantio Direto (SPD) e pastagens estáveis.</a:t>
+              <a:t>Amostragem em áreas sob Sistema Plantio Direto (SPD) consolidado e pastagens estáveis.</a:t>
             </a:r>
           </a:p>
           <a:p>
@@ -10300,7 +11356,7 @@
                   <a:srgbClr val="0F172A"/>
                 </a:solidFill>
               </a:rPr>
-              <a:t>Prevenção do 'Mock': </a:t>
+              <a:t>Prevenção de Vícios: </a:t>
             </a:r>
             <a:r>
               <a:rPr sz="1019">
@@ -10308,7 +11364,7 @@
                   <a:srgbClr val="475569"/>
                 </a:solidFill>
               </a:rPr>
-              <a:t>Garante que o modelo aprenda o contraste biofísico real entre equilíbrio e degradação.</a:t>
+              <a:t>Garante que o classificador aprenda o contraste biofísico real entre equilíbrio e degradação.</a:t>
             </a:r>
           </a:p>
         </p:txBody>
@@ -10442,7 +11498,7 @@
           <a:lstStyle/>
           <a:p>
             <a:pPr>
-              <a:defRPr sz="2200" b="1">
+              <a:defRPr sz="2100" b="1">
                 <a:solidFill>
                   <a:srgbClr val="FFFFFF"/>
                 </a:solidFill>
@@ -10658,7 +11714,7 @@
                   <a:srgbClr val="475569"/>
                 </a:solidFill>
               </a:rPr>
-              <a:t>NDVI (vigor vegetal) e BSI (Bare Soil Index) computados pixel a pixel na série temporal.</a:t>
+              <a:t>NDVI (cobertura fotossintética) e BSI (Bare Soil Index) computados pixel a pixel na série.</a:t>
             </a:r>
           </a:p>
           <a:p>
@@ -10673,7 +11729,7 @@
                   <a:srgbClr val="0F172A"/>
                 </a:solidFill>
               </a:rPr>
-              <a:t>Máscara de Nuvens SCL: </a:t>
+              <a:t>Discriminação de Palhada: </a:t>
             </a:r>
             <a:r>
               <a:rPr sz="1000">
@@ -10681,7 +11737,7 @@
                   <a:srgbClr val="475569"/>
                 </a:solidFill>
               </a:rPr>
-              <a:t>Filtro Scene Classification Layer com descarte de pixels nublados sem reposição de constantes.</a:t>
+              <a:t>O BSI permite discriminar solo exposto de palhada seca em áreas de plantio direto.</a:t>
             </a:r>
           </a:p>
         </p:txBody>
@@ -10962,7 +12018,7 @@
                   <a:srgbClr val="475569"/>
                 </a:solidFill>
               </a:rPr>
-              <a:t>Tendência temporal (b1), amplitudes anual/semianual e fases espectrais de cada comprimento de onda.</a:t>
+              <a:t>Tendência temporal (b1), amplitudes anual/semianual e fases espectrais sazonais.</a:t>
             </a:r>
           </a:p>
           <a:p>
@@ -10977,7 +12033,7 @@
                   <a:srgbClr val="0F172A"/>
                 </a:solidFill>
               </a:rPr>
-              <a:t>Métricas de Qualidade: </a:t>
+              <a:t>Métricas de Ajuste: </a:t>
             </a:r>
             <a:r>
               <a:rPr sz="1000">
@@ -11091,7 +12147,7 @@
                   <a:srgbClr val="475569"/>
                 </a:solidFill>
               </a:rPr>
-              <a:t>Fração temporal em que o solo permaneceu descoberto nos anos de monitoramento.</a:t>
+              <a:t>Fração temporal em que o solo permaneceu descoberto ao longo da série histórica.</a:t>
             </a:r>
           </a:p>
           <a:p>
@@ -11129,7 +12185,7 @@
                   <a:srgbClr val="0F172A"/>
                 </a:solidFill>
               </a:rPr>
-              <a:t>Mês Modal de Exposição: </a:t>
+              <a:t>Sazonalidade: </a:t>
             </a:r>
             <a:r>
               <a:rPr sz="1000">
@@ -11137,7 +12193,7 @@
                   <a:srgbClr val="475569"/>
                 </a:solidFill>
               </a:rPr>
-              <a:t>Identifica o período do ano com maior vulnerabilidade climática no Paraná.</a:t>
+              <a:t>Identifica a época do ano com maior vulnerabilidade a chuvas intensas no Paraná.</a:t>
             </a:r>
           </a:p>
         </p:txBody>
@@ -11271,7 +12327,7 @@
           <a:lstStyle/>
           <a:p>
             <a:pPr>
-              <a:defRPr sz="2200" b="1">
+              <a:defRPr sz="2100" b="1">
                 <a:solidFill>
                   <a:srgbClr val="FFFFFF"/>
                 </a:solidFill>
@@ -11559,7 +12615,7 @@
                   <a:srgbClr val="0F172A"/>
                 </a:solidFill>
               </a:rPr>
-              <a:t>Sem Cortes Disfarçados: </a:t>
+              <a:t>Domínio Físico: </a:t>
             </a:r>
             <a:r>
               <a:rPr sz="980">
@@ -11567,7 +12623,7 @@
                   <a:srgbClr val="475569"/>
                 </a:solidFill>
               </a:rPr>
-              <a:t>NDVI estritamente contido em [-1, 1], garantindo C contido em [0, 1] sem Math.min/max artificiais.</a:t>
+              <a:t>NDVI contido em [-1, 1], garantindo C contido em [0, 1] de forma analítica e verificável.</a:t>
             </a:r>
           </a:p>
           <a:p>
@@ -11696,7 +12752,7 @@
                   <a:srgbClr val="475569"/>
                 </a:solidFill>
               </a:rPr>
-              <a:t>Fator P = 1,0 quando as práticas mecânicas do imóvel forem desconhecidas (Renard et al., 1997).</a:t>
+              <a:t>Fator P = 1,0 quando as práticas conservacionistas do imóvel forem desconhecidas (Renard et al., 1997).</a:t>
             </a:r>
           </a:p>
           <a:p>
@@ -11719,7 +12775,7 @@
                   <a:srgbClr val="475569"/>
                 </a:solidFill>
               </a:rPr>
-              <a:t>Registrado estritamente como 'tabelado', nunca apresentado à banca como se fosse medição de campo.</a:t>
+              <a:t>Registrado estritamente como 'tabelado', nunca apresentado como medição de campo.</a:t>
             </a:r>
           </a:p>
           <a:p>
@@ -11734,7 +12790,7 @@
                   <a:srgbClr val="0F172A"/>
                 </a:solidFill>
               </a:rPr>
-              <a:t>Terraceamento: </a:t>
+              <a:t>Adequação na Rotulagem: </a:t>
             </a:r>
             <a:r>
               <a:rPr sz="980">
@@ -11742,7 +12798,7 @@
                   <a:srgbClr val="475569"/>
                 </a:solidFill>
               </a:rPr>
-              <a:t>Ajustável na rotulagem presencial caso terraços de retenção íntegros sejam comprovados.</a:t>
+              <a:t>Ajustável na rotulagem presencial caso terraços de retenção íntegros sejam observados.</a:t>
             </a:r>
           </a:p>
         </p:txBody>
@@ -11840,7 +12896,7 @@
                   <a:srgbClr val="0F172A"/>
                 </a:solidFill>
               </a:rPr>
-              <a:t>Trava Inviolável (Regra 9): </a:t>
+              <a:t>Trava Metodológica (Regra 9): </a:t>
             </a:r>
             <a:r>
               <a:rPr sz="980">
@@ -11848,7 +12904,7 @@
                   <a:srgbClr val="475569"/>
                 </a:solidFill>
               </a:rPr>
-              <a:t>Enquanto as equações não forem formalmente selecionadas pelo pesquisador, permanecem pendentes.</a:t>
+              <a:t>Enquanto as equações não forem formalmente deliberadas pelo pesquisador, permanecem pendentes.</a:t>
             </a:r>
           </a:p>
           <a:p>
@@ -11871,7 +12927,7 @@
                   <a:srgbClr val="475569"/>
                 </a:solidFill>
               </a:rPr>
-              <a:t>Perda de solo fica 'indisponivel (decisao-pendente)'. Proibido usar multiplicadores inventados.</a:t>
+              <a:t>Perda de solo fica 'indisponivel (decisao-pendente)'. Proibido usar multiplicadores arbitrários.</a:t>
             </a:r>
           </a:p>
           <a:p>
@@ -12028,7 +13084,7 @@
           <a:lstStyle/>
           <a:p>
             <a:pPr>
-              <a:defRPr sz="2200" b="1">
+              <a:defRPr sz="2100" b="1">
                 <a:solidFill>
                   <a:srgbClr val="FFFFFF"/>
                 </a:solidFill>
@@ -12244,7 +13300,7 @@
                   <a:srgbClr val="475569"/>
                 </a:solidFill>
               </a:rPr>
-              <a:t>Identificador único federal de cada imóvel cadastrado no Paraná.</a:t>
+              <a:t>Identificador único federal de cada imóvel rural cadastrado no Paraná.</a:t>
             </a:r>
           </a:p>
           <a:p>
@@ -12290,7 +13346,7 @@
                   <a:srgbClr val="475569"/>
                 </a:solidFill>
               </a:rPr>
-              <a:t>Polígono georreferenciado da propriedade para conferência de limites e confrontantes.</a:t>
+              <a:t>Polígono georreferenciado da propriedade para conferência de limites territoriais.</a:t>
             </a:r>
           </a:p>
         </p:txBody>
@@ -12419,7 +13475,7 @@
                   <a:srgbClr val="475569"/>
                 </a:solidFill>
               </a:rPr>
-              <a:t>Certificação de georreferenciamento de imóveis rurais com alta precisão métrica.</a:t>
+              <a:t>Certificação de georreferenciamento de imóveis rurais com precisão de agrimensura.</a:t>
             </a:r>
           </a:p>
           <a:p>
@@ -12434,7 +13490,7 @@
                   <a:srgbClr val="0F172A"/>
                 </a:solidFill>
               </a:rPr>
-              <a:t>Segurança Jurídica: </a:t>
+              <a:t>Segurança Registral: </a:t>
             </a:r>
             <a:r>
               <a:rPr sz="1000">
@@ -12457,7 +13513,7 @@
                   <a:srgbClr val="0F172A"/>
                 </a:solidFill>
               </a:rPr>
-              <a:t>Anotação Técnica: </a:t>
+              <a:t>Responsabilidade Técnica: </a:t>
             </a:r>
             <a:r>
               <a:rPr sz="1000">
@@ -12465,7 +13521,7 @@
                   <a:srgbClr val="475569"/>
                 </a:solidFill>
               </a:rPr>
-              <a:t>Registro de ART/CREA do engenheiro agrimensor responsável pela demarcação.</a:t>
+              <a:t>Registro de ART/CREA do engenheiro responsável pela demarcação.</a:t>
             </a:r>
           </a:p>
         </p:txBody>
@@ -12548,7 +13604,7 @@
               </a:defRPr>
             </a:pPr>
             <a:r>
-              <a:t>SNCR / Receita Federal</a:t>
+              <a:t>SNCR / INCRA</a:t>
             </a:r>
           </a:p>
           <a:p>
@@ -12586,6 +13642,29 @@
                   <a:srgbClr val="0F172A"/>
                 </a:solidFill>
               </a:rPr>
+              <a:t>Base Legal: </a:t>
+            </a:r>
+            <a:r>
+              <a:rPr sz="1000">
+                <a:solidFill>
+                  <a:srgbClr val="475569"/>
+                </a:solidFill>
+              </a:rPr>
+              <a:t>Sistema Nacional de Cadastro Rural instituído pela Lei 5.868/1972.</a:t>
+            </a:r>
+          </a:p>
+          <a:p>
+            <a:pPr>
+              <a:spcAft>
+                <a:spcPts val="400"/>
+              </a:spcAft>
+            </a:pPr>
+            <a:r>
+              <a:rPr b="1" sz="1000">
+                <a:solidFill>
+                  <a:srgbClr val="0F172A"/>
+                </a:solidFill>
+              </a:rPr>
               <a:t>Viabilização do Acesso: </a:t>
             </a:r>
             <a:r>
@@ -12594,7 +13673,7 @@
                   <a:srgbClr val="475569"/>
                 </a:solidFill>
               </a:rPr>
-              <a:t>Permite que a equipe de campo contate o produtor para autorização de entrada na fazenda.</a:t>
+              <a:t>Permite que a equipe de campo contate o produtor para solicitar autorização de visita.</a:t>
             </a:r>
           </a:p>
           <a:p>
@@ -12609,7 +13688,7 @@
                   <a:srgbClr val="0F172A"/>
                 </a:solidFill>
               </a:rPr>
-              <a:t>Cruzamento Local R*Tree: </a:t>
+              <a:t>Indexação Espacial R*Tree: </a:t>
             </a:r>
             <a:r>
               <a:rPr sz="1000">
@@ -12617,30 +13696,7 @@
                   <a:srgbClr val="475569"/>
                 </a:solidFill>
               </a:rPr>
-              <a:t>Consultas espaciais executadas em menos de 5ms no banco SQLite local.</a:t>
-            </a:r>
-          </a:p>
-          <a:p>
-            <a:pPr>
-              <a:spcAft>
-                <a:spcPts val="400"/>
-              </a:spcAft>
-            </a:pPr>
-            <a:r>
-              <a:rPr b="1" sz="1000">
-                <a:solidFill>
-                  <a:srgbClr val="0F172A"/>
-                </a:solidFill>
-              </a:rPr>
-              <a:t>Total Imunidade: </a:t>
-            </a:r>
-            <a:r>
-              <a:rPr sz="1000">
-                <a:solidFill>
-                  <a:srgbClr val="475569"/>
-                </a:solidFill>
-              </a:rPr>
-              <a:t>Zero divergências cadastrais atestadas na auditoria contra os dados abertos oficiais.</a:t>
+              <a:t>Consultas espaciais executadas em milissegundos no banco SQLite local.</a:t>
             </a:r>
           </a:p>
         </p:txBody>
@@ -12732,7 +13788,7 @@
               </a:defRPr>
             </a:pPr>
             <a:r>
-              <a:t>Os dados fundiários servem exclusivamente à gestão operacional de acesso em campo e nunca entram na matriz de treino do XGBoost. Nomes e documentos de titulares são mascarados byte a byte pela máscara oficial do SNCR. Rotas fundiárias e tokens transitam em sessões efêmeras no servidor, com recusa automática a conexões externas.</a:t>
+              <a:t>Os dados fundiários servem exclusivamente à gestão operacional de acesso em campo e nunca entram na matriz de treino do XGBoost. Nomes e documentos de titulares são mascarados na visualização. Rotas fundiárias e tokens transitam em sessões efêmeras no servidor, com recusa a conexões externas.</a:t>
             </a:r>
           </a:p>
         </p:txBody>

</xml_diff>

<commit_message>
feat(integracao): estruturar configuracao da api jev e documentar justificativa tecnica metodologica
</commit_message>
<xml_diff>
--- a/Apresentacao_SAREL_PPGTCA_2026.pptx
+++ b/Apresentacao_SAREL_PPGTCA_2026.pptx
@@ -6317,8 +6317,8 @@
         </p:nvSpPr>
         <p:spPr>
           <a:xfrm>
-            <a:off x="731520" y="1417320"/>
-            <a:ext cx="5212080" cy="2240280"/>
+            <a:off x="731520" y="1371600"/>
+            <a:ext cx="5212080" cy="2331720"/>
           </a:xfrm>
           <a:prstGeom prst="roundRect">
             <a:avLst/>
@@ -6362,8 +6362,8 @@
         </p:nvSpPr>
         <p:spPr>
           <a:xfrm>
-            <a:off x="914400" y="1600200"/>
-            <a:ext cx="4846320" cy="1874520"/>
+            <a:off x="914400" y="1554480"/>
+            <a:ext cx="4846320" cy="1965960"/>
           </a:xfrm>
           <a:prstGeom prst="rect">
             <a:avLst/>
@@ -6380,14 +6380,14 @@
               <a:spcAft>
                 <a:spcPts val="500"/>
               </a:spcAft>
-              <a:defRPr sz="1300" b="1">
+              <a:defRPr sz="1250" b="1">
                 <a:solidFill>
                   <a:srgbClr val="D97706"/>
                 </a:solidFill>
               </a:defRPr>
             </a:pPr>
             <a:r>
-              <a:t>Resolução Espacial de 30 metros</a:t>
+              <a:t>Resolução Espacial de 30m (Copernicus DEM)</a:t>
             </a:r>
           </a:p>
           <a:p>
@@ -6397,20 +6397,20 @@
               </a:spcAft>
             </a:pPr>
             <a:r>
-              <a:rPr b="1" sz="1000">
+              <a:rPr b="1" sz="919">
                 <a:solidFill>
                   <a:srgbClr val="0F172A"/>
                 </a:solidFill>
               </a:rPr>
-              <a:t>Tamanho do Pixel: </a:t>
-            </a:r>
-            <a:r>
-              <a:rPr sz="1000">
+              <a:t>Limitação do Pixel: </a:t>
+            </a:r>
+            <a:r>
+              <a:rPr sz="919">
                 <a:solidFill>
                   <a:srgbClr val="475569"/>
                 </a:solidFill>
               </a:rPr>
-              <a:t>Copernicus DEM (30m) suaviza microtopografia, feições de microrrelevo e terraços estreitos.</a:t>
+              <a:t>Copernicus DEM (30m) suaviza microtopografia, terraços de retenção (2–6m) e microcanais.</a:t>
             </a:r>
           </a:p>
           <a:p>
@@ -6420,7 +6420,7 @@
               </a:spcAft>
             </a:pPr>
             <a:r>
-              <a:rPr b="1" sz="1000">
+              <a:rPr b="1" sz="919">
                 <a:solidFill>
                   <a:srgbClr val="0F172A"/>
                 </a:solidFill>
@@ -6428,12 +6428,12 @@
               <a:t>Consequência: </a:t>
             </a:r>
             <a:r>
-              <a:rPr sz="1000">
+              <a:rPr sz="919">
                 <a:solidFill>
                   <a:srgbClr val="475569"/>
                 </a:solidFill>
               </a:rPr>
-              <a:t>Pode subestimar localmente a declividade em talvegues abruptos ou rupturas de declive acentuadas.</a:t>
+              <a:t>Pode subestimar localmente o gradiente hidráulico em talvegues abruptos ou rupturas de declive.</a:t>
             </a:r>
           </a:p>
           <a:p>
@@ -6443,20 +6443,20 @@
               </a:spcAft>
             </a:pPr>
             <a:r>
-              <a:rPr b="1" sz="1000">
+              <a:rPr b="1" sz="919">
                 <a:solidFill>
                   <a:srgbClr val="0F172A"/>
                 </a:solidFill>
               </a:rPr>
-              <a:t>Atenuação: </a:t>
-            </a:r>
-            <a:r>
-              <a:rPr sz="1000">
+              <a:t>Compensação Implantada: </a:t>
+            </a:r>
+            <a:r>
+              <a:rPr sz="919">
                 <a:solidFill>
                   <a:srgbClr val="475569"/>
                 </a:solidFill>
               </a:rPr>
-              <a:t>Uso complementar de ortomosaicos de drone (GSD &lt; 5cm) nas áreas de calibração presencial.</a:t>
+              <a:t>Abordagem multiescala: macro-triagem no GEE + PlanetScope (3m) na rotulagem cega + drone (&lt; 5cm) no campo.</a:t>
             </a:r>
           </a:p>
         </p:txBody>
@@ -6469,8 +6469,8 @@
         </p:nvSpPr>
         <p:spPr>
           <a:xfrm>
-            <a:off x="6217920" y="1417320"/>
-            <a:ext cx="5212080" cy="2240280"/>
+            <a:off x="6217920" y="1371600"/>
+            <a:ext cx="5212080" cy="2331720"/>
           </a:xfrm>
           <a:prstGeom prst="roundRect">
             <a:avLst/>
@@ -6514,8 +6514,8 @@
         </p:nvSpPr>
         <p:spPr>
           <a:xfrm>
-            <a:off x="6400800" y="1600200"/>
-            <a:ext cx="4846320" cy="1874520"/>
+            <a:off x="6400800" y="1554480"/>
+            <a:ext cx="4846320" cy="1965960"/>
           </a:xfrm>
           <a:prstGeom prst="rect">
             <a:avLst/>
@@ -6532,7 +6532,7 @@
               <a:spcAft>
                 <a:spcPts val="500"/>
               </a:spcAft>
-              <a:defRPr sz="1300" b="1">
+              <a:defRPr sz="1250" b="1">
                 <a:solidFill>
                   <a:srgbClr val="E11D48"/>
                 </a:solidFill>
@@ -6549,20 +6549,20 @@
               </a:spcAft>
             </a:pPr>
             <a:r>
-              <a:rPr b="1" sz="1000">
+              <a:rPr b="1" sz="919">
                 <a:solidFill>
                   <a:srgbClr val="0F172A"/>
                 </a:solidFill>
               </a:rPr>
-              <a:t>Região Sul do Brasil: </a:t>
-            </a:r>
-            <a:r>
-              <a:rPr sz="1000">
+              <a:t>Desafio Subtropical: </a:t>
+            </a:r>
+            <a:r>
+              <a:rPr sz="919">
                 <a:solidFill>
                   <a:srgbClr val="475569"/>
                 </a:solidFill>
               </a:rPr>
-              <a:t>Elevada nebulosidade em períodos chuvosos críticos de primavera e verão.</a:t>
+              <a:t>Alta nebulosidade convectiva no Paraná durante as safras de primavera e verão (outubro a março).</a:t>
             </a:r>
           </a:p>
           <a:p>
@@ -6572,7 +6572,7 @@
               </a:spcAft>
             </a:pPr>
             <a:r>
-              <a:rPr b="1" sz="1000">
+              <a:rPr b="1" sz="919">
                 <a:solidFill>
                   <a:srgbClr val="0F172A"/>
                 </a:solidFill>
@@ -6580,12 +6580,12 @@
               <a:t>Consequência: </a:t>
             </a:r>
             <a:r>
-              <a:rPr sz="1000">
+              <a:rPr sz="919">
                 <a:solidFill>
                   <a:srgbClr val="475569"/>
                 </a:solidFill>
               </a:rPr>
-              <a:t>Redução do número de imagens úteis no Sentinel-2 e janelas de observação truncadas.</a:t>
+              <a:t>Redução de passagens ópticas úteis do Sentinel-2 (ciclo de 5 dias) em janelas críticas pós-plantio.</a:t>
             </a:r>
           </a:p>
           <a:p>
@@ -6595,20 +6595,20 @@
               </a:spcAft>
             </a:pPr>
             <a:r>
-              <a:rPr b="1" sz="1000">
+              <a:rPr b="1" sz="919">
                 <a:solidFill>
                   <a:srgbClr val="0F172A"/>
                 </a:solidFill>
               </a:rPr>
-              <a:t>Atenuação: </a:t>
-            </a:r>
-            <a:r>
-              <a:rPr sz="1000">
+              <a:t>Compensação Implantada: </a:t>
+            </a:r>
+            <a:r>
+              <a:rPr sz="919">
                 <a:solidFill>
                   <a:srgbClr val="475569"/>
                 </a:solidFill>
               </a:rPr>
-              <a:t>Composição temporal com BSI, máscaras estritas de nuvem/sombra e séries de múltiplos anos.</a:t>
+              <a:t>Revisita quase diária do PlanetScope, radar Sentinel-1 (C-band penetra nuvem em T0) e filtro UDM2 por AOI.</a:t>
             </a:r>
           </a:p>
         </p:txBody>
@@ -6622,7 +6622,7 @@
         <p:spPr>
           <a:xfrm>
             <a:off x="731520" y="3840480"/>
-            <a:ext cx="5212080" cy="2240280"/>
+            <a:ext cx="5212080" cy="2331720"/>
           </a:xfrm>
           <a:prstGeom prst="roundRect">
             <a:avLst/>
@@ -6667,7 +6667,7 @@
         <p:spPr>
           <a:xfrm>
             <a:off x="914400" y="4023360"/>
-            <a:ext cx="4846320" cy="1874520"/>
+            <a:ext cx="4846320" cy="1965960"/>
           </a:xfrm>
           <a:prstGeom prst="rect">
             <a:avLst/>
@@ -6684,7 +6684,7 @@
               <a:spcAft>
                 <a:spcPts val="500"/>
               </a:spcAft>
-              <a:defRPr sz="1300" b="1">
+              <a:defRPr sz="1250" b="1">
                 <a:solidFill>
                   <a:srgbClr val="6366F1"/>
                 </a:solidFill>
@@ -6701,20 +6701,20 @@
               </a:spcAft>
             </a:pPr>
             <a:r>
-              <a:rPr b="1" sz="1000">
+              <a:rPr b="1" sz="919">
                 <a:solidFill>
                   <a:srgbClr val="0F172A"/>
                 </a:solidFill>
               </a:rPr>
-              <a:t>Acesso aos Imóveis: </a:t>
-            </a:r>
-            <a:r>
-              <a:rPr sz="1000">
+              <a:t>Desafio Fundiário: </a:t>
+            </a:r>
+            <a:r>
+              <a:rPr sz="919">
                 <a:solidFill>
                   <a:srgbClr val="475569"/>
                 </a:solidFill>
               </a:rPr>
-              <a:t>A validação presencial exige autorização formal de entrada pelo titular do imóvel rural.</a:t>
+              <a:t>Validação presencial de campo (20%) exige autorização formal de acesso ao imóvel rural (CAR/SIGEF).</a:t>
             </a:r>
           </a:p>
           <a:p>
@@ -6724,7 +6724,7 @@
               </a:spcAft>
             </a:pPr>
             <a:r>
-              <a:rPr b="1" sz="1000">
+              <a:rPr b="1" sz="919">
                 <a:solidFill>
                   <a:srgbClr val="0F172A"/>
                 </a:solidFill>
@@ -6732,12 +6732,12 @@
               <a:t>Consequência: </a:t>
             </a:r>
             <a:r>
-              <a:rPr sz="1000">
+              <a:rPr sz="919">
                 <a:solidFill>
                   <a:srgbClr val="475569"/>
                 </a:solidFill>
               </a:rPr>
-              <a:t>Possível viés amostral de proprietários mais colaborativos e com manejo potencialmente superior.</a:t>
+              <a:t>Risco de amostragem viciada em proprietários mais solícitos, com práticas conservacionistas superiores.</a:t>
             </a:r>
           </a:p>
           <a:p>
@@ -6747,20 +6747,20 @@
               </a:spcAft>
             </a:pPr>
             <a:r>
-              <a:rPr b="1" sz="1000">
+              <a:rPr b="1" sz="919">
                 <a:solidFill>
                   <a:srgbClr val="0F172A"/>
                 </a:solidFill>
               </a:rPr>
-              <a:t>Atenuação: </a:t>
-            </a:r>
-            <a:r>
-              <a:rPr sz="1000">
+              <a:t>Compensação Metodológica: </a:t>
+            </a:r>
+            <a:r>
+              <a:rPr sz="919">
                 <a:solidFill>
                   <a:srgbClr val="475569"/>
                 </a:solidFill>
               </a:rPr>
-              <a:t>Condução de fotointerpretação cega independente e geolocalização com amostragem balanceada.</a:t>
+              <a:t>Dupla cegueira: Fase A (PlanetScope 3m) cobre 100% da amostra sem viés; auditoria Kappa (IC 95%) afere desvios.</a:t>
             </a:r>
           </a:p>
         </p:txBody>
@@ -6774,7 +6774,7 @@
         <p:spPr>
           <a:xfrm>
             <a:off x="6217920" y="3840480"/>
-            <a:ext cx="5212080" cy="2240280"/>
+            <a:ext cx="5212080" cy="2331720"/>
           </a:xfrm>
           <a:prstGeom prst="roundRect">
             <a:avLst/>
@@ -6819,7 +6819,7 @@
         <p:spPr>
           <a:xfrm>
             <a:off x="6400800" y="4023360"/>
-            <a:ext cx="4846320" cy="1874520"/>
+            <a:ext cx="4846320" cy="1965960"/>
           </a:xfrm>
           <a:prstGeom prst="rect">
             <a:avLst/>
@@ -6836,7 +6836,7 @@
               <a:spcAft>
                 <a:spcPts val="500"/>
               </a:spcAft>
-              <a:defRPr sz="1300" b="1">
+              <a:defRPr sz="1250" b="1">
                 <a:solidFill>
                   <a:srgbClr val="0EA5E9"/>
                 </a:solidFill>
@@ -6853,7 +6853,7 @@
               </a:spcAft>
             </a:pPr>
             <a:r>
-              <a:rPr b="1" sz="1000">
+              <a:rPr b="1" sz="919">
                 <a:solidFill>
                   <a:srgbClr val="0F172A"/>
                 </a:solidFill>
@@ -6861,12 +6861,12 @@
               <a:t>Dinâmica Agrícola: </a:t>
             </a:r>
             <a:r>
-              <a:rPr sz="1000">
+              <a:rPr sz="919">
                 <a:solidFill>
                   <a:srgbClr val="475569"/>
                 </a:solidFill>
               </a:rPr>
-              <a:t>Eventos de chuva intensa podem ocorrer entre as passagens orbitais de 5 dias do Sentinel-2.</a:t>
+              <a:t>Enxurradas ocorrem entre passagens orbitais; o rápido rebrote e cobertura mascaram a erosão laminar.</a:t>
             </a:r>
           </a:p>
           <a:p>
@@ -6876,7 +6876,7 @@
               </a:spcAft>
             </a:pPr>
             <a:r>
-              <a:rPr b="1" sz="1000">
+              <a:rPr b="1" sz="919">
                 <a:solidFill>
                   <a:srgbClr val="0F172A"/>
                 </a:solidFill>
@@ -6884,12 +6884,12 @@
               <a:t>Consequência: </a:t>
             </a:r>
             <a:r>
-              <a:rPr sz="1000">
+              <a:rPr sz="919">
                 <a:solidFill>
                   <a:srgbClr val="475569"/>
                 </a:solidFill>
               </a:rPr>
-              <a:t>Erosão ocorrida logo após o preparo do solo pode ser mascarada pelo rápido crescimento de plantas.</a:t>
+              <a:t>Marcas efêmeras de erosão laminar podem desaparecer antes de uma cena óptica sem nuvens.</a:t>
             </a:r>
           </a:p>
           <a:p>
@@ -6899,20 +6899,20 @@
               </a:spcAft>
             </a:pPr>
             <a:r>
-              <a:rPr b="1" sz="1000">
+              <a:rPr b="1" sz="919">
                 <a:solidFill>
                   <a:srgbClr val="0F172A"/>
                 </a:solidFill>
               </a:rPr>
-              <a:t>Atenuação: </a:t>
-            </a:r>
-            <a:r>
-              <a:rPr sz="1000">
+              <a:t>Compensação Metodológica: </a:t>
+            </a:r>
+            <a:r>
+              <a:rPr sz="919">
                 <a:solidFill>
                   <a:srgbClr val="475569"/>
                 </a:solidFill>
               </a:rPr>
-              <a:t>Registro da data exata de cada observação e análise da série histórica de solo exposto (Ê).</a:t>
+              <a:t>Pares de evento (trio T-, T0, T+ com CHIRPS/IMERG) e métrica harmônica contínua de solo exposto (Ê).</a:t>
             </a:r>
           </a:p>
         </p:txBody>

</xml_diff>